<commit_message>
polish rag coursework deliverables
</commit_message>
<xml_diff>
--- a/slides/redis_rag_presentation.pptx
+++ b/slides/redis_rag_presentation.pptx
@@ -516,13 +516,8 @@
           <a:p>
             <a:r>
               <a:rPr lang="en-US" dirty="0"/>
-              <a:t>第 1 页：封面
-页面内容：
-Redis-RAG：基于 RAG 的 Redis 垂直领域深度问答系统
-关键词：私有知识库、混合检索、DeepSeek 生成、三维量化评估
-交付物：代码仓库、README、依赖文件、一键推理、报告、PPT、讲稿
-讲稿：
-这一页是汇报封面。我的作业选题是 Redis 垂直领域问答系统。核心思路是把 Redis 官方文档和清洗后的技术语料构造成私有知识库，然后通过 RAG 的方式进行检索增强生成。系统不仅包含一键推理脚本，也包含索引构建、量化评估、报告和 PPT。后面我会按照数据、检索、生成、评估和案例分析的顺序展开。</a:t>
+              <a:t>这一页是汇报封面。我的作业选题是 Redis 垂直领域问答系统。核心思路是把 Redis 官方文档和清洗后的技术语料构造成私有知识库，然后通过 RAG 的方式进行检索增强生成。系统不仅包含一键推理脚本，也包含索引构建、量化评估、报告和 PPT。后面我会按照数据、检索、生成、评估和案例分析的顺序展开。
+这一页我还会顺着画面把这些信息讲清楚：Redis-RAG：基于 RAG 的 Redis 垂直领域深度问答系统；关键词：私有知识库、混合检索、DeepSeek 生成、三维量化评估；交付物：代码仓库、README、依赖文件、一键推理、报告、PPT、讲稿。讲的时候不需要停留在单个词上，而是把它们串成“为什么这样设计、系统如何实现、结果说明什么”这条线索。</a:t>
             </a:r>
             <a:endParaRPr lang="en-US" dirty="0"/>
           </a:p>
@@ -610,14 +605,8 @@
           <a:p>
             <a:r>
               <a:rPr lang="en-US" dirty="0"/>
-              <a:t>第 10 页：端到端系统架构
-页面内容：
-文档 JSONL 经过 Chunking 后进入 Embedding 和 BM25
-用户问题经过 Query Rewriting 后进入 Hybrid Retriever
-Top-k 上下文传入 DeepSeek 或抽取式生成器
-输出带引用答案和检索分数
-讲稿：
-这一页展示端到端架构。左边是文档处理和索引构建，文档先变成 chunk，再进入 embedding 和 BM25。右边是在线问答流程，用户问题先经过 Query Rewriting，然后由 Hybrid Retriever 找到 Top-k 上下文，最后传给 DeepSeek 或抽取式生成器。系统还会输出检索分数，便于分析为什么选中某个文档。</a:t>
+              <a:t>这一页展示端到端架构。左边是文档处理和索引构建，文档先变成 chunk，再进入 embedding 和 BM25。右边是在线问答流程，用户问题先经过 Query Rewriting，然后由 Hybrid Retriever 找到候选上下文，再经过轻量 reranker 根据术语覆盖率和标题覆盖率做二次排序。最后系统把高质量上下文传给 DeepSeek 或抽取式生成器，并输出带引用答案。这样设计的重点是可观测、可替换和可复现：检索分数能看到，embedding 和向量库能替换，没有 API key 时也能跑完整流程。
+这一页我还会顺着画面把这些信息讲清楚：文档 JSONL 经过 Chunking 后进入 Embedding 和 BM25；用户问题经过 Query Rewriting 后进入 Hybrid Retriever；Top-k 候选经过轻量 reranker 二次排序；最终上下文传入 DeepSeek 或抽取式生成器；输出带引用答案和可解释检索分数。讲的时候不需要停留在单个词上，而是把它们串成“为什么这样设计、系统如何实现、结果说明什么”这条线索。</a:t>
             </a:r>
             <a:endParaRPr lang="en-US" dirty="0"/>
           </a:p>
@@ -705,14 +694,8 @@
           <a:p>
             <a:r>
               <a:rPr lang="en-US" dirty="0"/>
-              <a:t>第 11 页：生成模块：DeepSeek 优先，离线可回退
-页面内容：
-设置 DEEPSEEK_API_KEY 后默认使用 deepseek-v4-pro
-没有 API key 时使用抽取式生成器
-提示词要求只能基于上下文回答，并带来源引用
-API key 不写入仓库
-讲稿：
-这一页说明生成模块。项目支持 DeepSeek，只要设置 DEEPSEEK_API_KEY，默认模型就是 deepseek-v4-pro。同时我保留了抽取式回退，保证没有 API key 也能运行。为了降低幻觉，系统提示要求模型只能依据检索上下文回答，并带引用。如果上下文不足，就要说明无法确认。这里也强调，API key 不会写入仓库，只通过环境变量传入。</a:t>
+              <a:t>这一页说明生成模块。项目支持 DeepSeek，只要设置 DEEPSEEK_API_KEY，默认模型就是 deepseek-v4-pro。同时我保留了抽取式回退，保证没有 API key 也能运行。为了降低幻觉，系统提示要求模型只能依据检索上下文回答，并带引用。如果上下文不足，就要说明无法确认。这里也强调，API key 不会写入仓库，只通过环境变量传入。
+这一页我还会顺着画面把这些信息讲清楚：设置 DEEPSEEK_API_KEY 后默认使用 deepseek-v4-pro；没有 API key 时使用抽取式生成器；提示词要求只能基于上下文回答，并带来源引用；API key 不写入仓库。讲的时候不需要停留在单个词上，而是把它们串成“为什么这样设计、系统如何实现、结果说明什么”这条线索。</a:t>
             </a:r>
             <a:endParaRPr lang="en-US" dirty="0"/>
           </a:p>
@@ -800,14 +783,8 @@
           <a:p>
             <a:r>
               <a:rPr lang="en-US" dirty="0"/>
-              <a:t>第 12 页：量化评估：三个维度衡量 RAG 能力
-页面内容：
-Context Relevance 衡量检索上下文是否相关
-Faithfulness 衡量答案是否忠实于上下文
-Answer Relevance 衡量答案是否回答问题
-评估集包含 10 条 Redis 技术问题
-讲稿：
-这一页介绍评估方案。Context Relevance 主要评价检索是否找到了相关文档。Faithfulness 评价答案是否被上下文支持，也就是是否有幻觉风险。Answer Relevance 评价答案是否覆盖问题的关键点。评估集包含 10 条 Redis 技术问题，输出结果会保存成 JSON 和 CSV，方便报告引用。</a:t>
+              <a:t>这一页介绍评估方案。Context Relevance 主要评价检索是否找到了相关文档。Faithfulness 评价答案是否被上下文支持，也就是是否有幻觉风险。Answer Relevance 评价答案是否覆盖问题的关键点。评估集包含 10 条 Redis 技术问题，输出结果会保存成 JSON 和 CSV，方便报告引用。
+这一页我还会顺着画面把这些信息讲清楚：Context Relevance 衡量检索上下文是否相关；Faithfulness 衡量答案是否忠实于上下文；Answer Relevance 衡量答案是否回答问题；评估集包含 10 条 Redis 技术问题。讲的时候不需要停留在单个词上，而是把它们串成“为什么这样设计、系统如何实现、结果说明什么”这条线索。</a:t>
             </a:r>
             <a:endParaRPr lang="en-US" dirty="0"/>
           </a:p>
@@ -895,14 +872,8 @@
           <a:p>
             <a:r>
               <a:rPr lang="en-US" dirty="0"/>
-              <a:t>第 13 页：实验结果与解释
-页面内容：
-Context Relevance = 1.0000
-Faithfulness = 0.8116
-Answer Relevance = 0.8750
-检索效果较稳，答案忠实度较好，部分关键词覆盖仍可提升
-讲稿：
-这一页展示实验结果。Context Relevance 是 1.0000，说明在当前评估集里，检索能覆盖相关文档。Faithfulness 是 0.8116，说明答案大多数内容都能被上下文支持。Answer Relevance 是 0.8750，说明答案基本覆盖问题要点，但还有提升空间。主要问题是抽取式生成有时表达比较硬，可能没有覆盖所有期望关键词。</a:t>
+              <a:t>这一页展示实验结果。图里的数值不是手工写的，而是实际运行 evaluate.py --rebuild 后从 outputs/eval_results.json 中读取并生成的。Context Relevance 是 1.0000，说明在当前评估集里，检索能覆盖相关文档。Faithfulness 是 0.8159，说明答案大多数内容都能被上下文支持。Answer Relevance 是 0.8750，说明答案基本覆盖问题要点，但还有提升空间。主要问题是抽取式生成有时表达比较硬，可能没有覆盖所有期望关键词；如果接入 DeepSeek 并加强引用校验，表达自然度会进一步提升。
+这一页我还会顺着画面把这些信息讲清楚：Context Relevance = 1.0000；Faithfulness = 0.8159；Answer Relevance = 0.8750；检索效果较稳，答案忠实度较好，部分关键词覆盖仍可提升。讲的时候不需要停留在单个词上，而是把它们串成“为什么这样设计、系统如何实现、结果说明什么”这条线索。</a:t>
             </a:r>
             <a:endParaRPr lang="en-US" dirty="0"/>
           </a:p>
@@ -990,14 +961,8 @@
           <a:p>
             <a:r>
               <a:rPr lang="en-US" dirty="0"/>
-              <a:t>第 14 页：案例分析：AOF 与 RDB 持久化问答
-页面内容：
-问题是 Redis 的 AOF 和 RDB 持久化有什么区别
-系统命中文档 redis:persistence
-答案包含 RDB 快照、AOF 追加日志、备份恢复和数据安全性
-命中原因是 Query Rewriting 和 BM25 精确术语匹配
-讲稿：
-这一页用 AOF 和 RDB 问题做案例。系统最终命中了 redis:persistence 文档，combined_score 是 1.0000。答案能解释 RDB 是快照，适合备份和快速恢复；AOF 是追加日志，通常数据安全性更好。这个案例能说明 Query Rewriting 和 BM25 的价值：中文问题会扩展到 persistence、snapshot 和 append only file，同时 AOF 和 RDB 被精确命中。</a:t>
+              <a:t>这一页用 AOF 和 RDB 问题做案例。这里放的是脚本真实运行输出，不是后期编造的截图。系统最终命中了 redis:persistence 文档，最终 score 是 1.0819，其中 hybrid combined_score 是 1.0000，reranker 又根据 AOF、RDB、persistence 等术语覆盖给了额外奖励。答案解释了 RDB 是快照，适合备份和快速恢复；AOF 是追加日志，通常数据安全性更好。这个案例能说明 Query Rewriting、BM25 精确术语匹配和轻量重排序的价值：中文问题会扩展到 persistence、snapshot 和 append only file，同时 AOF 和 RDB 被精确命中。
+这一页我还会顺着画面把这些信息讲清楚：问题是 Redis 的 AOF 和 RDB 持久化有什么区别；系统命中文档 redis:persistence；最终 score = 1.0819，说明 rerank 在 hybrid score 基础上加入术语覆盖奖励；答案包含 RDB 快照、AOF 追加日志、备份恢复和数据安全性；命中原因是 Query Rewriting、BM25 精确术语匹配和轻量重排序共同作用。讲的时候不需要停留在单个词上，而是把它们串成“为什么这样设计、系统如何实现、结果说明什么”这条线索。</a:t>
             </a:r>
             <a:endParaRPr lang="en-US" dirty="0"/>
           </a:p>
@@ -1085,14 +1050,8 @@
           <a:p>
             <a:r>
               <a:rPr lang="en-US" dirty="0"/>
-              <a:t>第 15 页：Bad Case、改进方向与总结
-页面内容：
-Bad Case：AOF/RDB 问题早期召回 Pub/Sub 弱相关文档
-已做改进：Query Rewriting、混合检索、上下文过滤
-后续优化：BGE embedding、reranker、更大评估集、citation checking
-复现实验命令：infer.py 和 evaluate.py
-讲稿：
-最后一页总结问题和改进。一个典型 bad case 是 AOF/RDB 问题早期会召回 Pub/Sub，因为它也出现了持久化相关词。为了解决这个问题，我加入了 Query Rewriting、混合检索和生成阶段上下文过滤。后续可以进一步替换 BGE embedding、增加 reranker、扩大评估集，并对 LLM 输出做引用一致性检查。总体来说，这个项目完成了从知识库到检索、生成、评估和展示的完整闭环。</a:t>
+              <a:t>最后一页总结问题和改进。表格来自 infer.py --json 的真实输出，可以看到 redis:persistence 排名第一，score 和 rerank_score 都是 1.0819，term_coverage 明显高于其他候选。一个典型 bad case 是 AOF/RDB 问题仍会召回 Pub/Sub，因为 Pub/Sub 文档也出现了“不会持久化”这类词。为了解决这个问题，我加入了 Query Rewriting、BM25/Vector 混合检索、轻量重排序和生成阶段上下文过滤。后续可以进一步替换 BGE embedding，接入 FAISS 或 Chroma，扩大评估集，并对 DeepSeek 输出做 citation checking。总体来说，这个项目完成了从知识库到检索、生成、评估和展示的完整闭环。
+这一页我还会顺着画面把这些信息讲清楚：真实 JSON 输出展示 score、combined_score、rerank_score 和 term_coverage；Bad Case：AOF/RDB 问题仍会召回 Pub/Sub 弱相关文档；已做改进：Query Rewriting、混合检索、轻量重排序和上下文过滤；后续优化：BGE embedding、FAISS/Chroma、更大评估集、citation checking。讲的时候不需要停留在单个词上，而是把它们串成“为什么这样设计、系统如何实现、结果说明什么”这条线索。</a:t>
             </a:r>
             <a:endParaRPr lang="en-US" dirty="0"/>
           </a:p>
@@ -1180,13 +1139,8 @@
           <a:p>
             <a:r>
               <a:rPr lang="en-US" dirty="0"/>
-              <a:t>第 2 页：作业要求与本项目交付
-页面内容：
-本项目交付完整代码仓库
-核心 RAG 模块包括知识库、Chunking、Embedding、向量库、混合检索和生成
-展示材料包括报告、PPT 和逐页讲稿
-讲稿：
-这一页说明作业要求和项目交付之间的对应关系。代码仓库里有 README、requirements 和 infer.py，满足一键运行要求。RAG 核心部分包括 Redis 私有知识库、文档分块、embedding、本地向量库、Query Rewriting 和混合检索。展示材料方面，我补充了论文式报告、PDF、15页PPT和逐页讲稿，所以这个项目既可以运行，也可以完整展示。</a:t>
+              <a:t>这一页说明作业要求和项目交付之间的对应关系。代码仓库里有 README、requirements 和 infer.py，满足一键运行要求。RAG 核心部分包括 Redis 私有知识库、文档分块、embedding、本地向量库、Query Rewriting、BM25/Vector 混合检索以及轻量重排序。展示材料方面，我把报告整理成 Markdown 和可编辑 Word，同时生成 PPT、演讲者备注和单独讲稿，所以这个项目既可以运行，也可以完整展示。
+这一页我还会顺着画面把这些信息讲清楚：本项目交付完整代码仓库；核心 RAG 模块包括知识库、Chunking、Embedding、向量库、混合检索、轻量重排序和生成；展示材料包括报告 Word、PPT、演讲者备注和讲稿。讲的时候不需要停留在单个词上，而是把它们串成“为什么这样设计、系统如何实现、结果说明什么”这条线索。</a:t>
             </a:r>
             <a:endParaRPr lang="en-US" dirty="0"/>
           </a:p>
@@ -1274,14 +1228,8 @@
           <a:p>
             <a:r>
               <a:rPr lang="en-US" dirty="0"/>
-              <a:t>第 3 页：为什么选 Redis 作为垂直领域
-页面内容：
-Redis 知识边界清晰
-Redis 问答包含大量命令名和缩写
-官方文档可追溯，适合做引用和忠实度评估
-技术文档 RAG 的难点包括术语匹配、概念混淆和答案忠实度
-讲稿：
-我选择 Redis 是因为它很适合作为垂直领域。第一，Redis 的知识边界清楚，主题从数据结构到持久化和集群都很明确。第二，Redis 问答里有很多精确术语，比如 AOF、RDB、TTL 和 WATCH，这些词非常考验检索系统。第三，官方文档有稳定 URL，可以作为答案引用来源。这个选题能很好地展示 RAG 的核心价值：把答案约束到可追溯的文档上下文中。</a:t>
+              <a:t>我选择 Redis 是因为它很适合作为垂直领域。第一，Redis 的知识边界清楚，主题从数据结构到持久化和集群都很明确。第二，Redis 问答里有很多精确术语，比如 AOF、RDB、TTL 和 WATCH，这些词非常考验检索系统。第三，官方文档有稳定 URL，可以作为答案引用来源。这个选题能很好地展示 RAG 的核心价值：把答案约束到可追溯的文档上下文中。
+这一页我还会顺着画面把这些信息讲清楚：Redis 知识边界清晰；Redis 问答包含大量命令名和缩写；官方文档可追溯，适合做引用和忠实度评估；技术文档 RAG 的难点包括术语匹配、概念混淆和答案忠实度。讲的时候不需要停留在单个词上，而是把它们串成“为什么这样设计、系统如何实现、结果说明什么”这条线索。</a:t>
             </a:r>
             <a:endParaRPr lang="en-US" dirty="0"/>
           </a:p>
@@ -1369,13 +1317,8 @@
           <a:p>
             <a:r>
               <a:rPr lang="en-US" dirty="0"/>
-              <a:t>第 4 页：私有知识库构建流程
-页面内容：
-流程：官方文档、页面抓取、正文清洗、JSONL 语料、索引构建、问答系统
-每条文档包含 doc_id、title、url、text
-知识主题覆盖 Redis 数据结构、TTL、持久化、高可用、集群和缓存风险
-讲稿：
-这一页展示私有知识库构建流程。数据可以来自 Redis 官方文档，经过页面抓取和正文清洗后，保存为 JSONL。每条记录都包含 doc_id、title、url 和 text。doc_id 用于评估，url 用于追溯来源。为了保证作业能稳定运行，我保留了一份内置清洗语料，同时也提供脚本重新抓取官方文档。</a:t>
+              <a:t>这一页展示私有知识库构建流程。数据可以来自 Redis 官方文档，经过页面抓取和正文清洗后，保存为 JSONL。每条记录都包含 doc_id、title、url 和 text。doc_id 用于评估，url 用于追溯来源。为了保证作业能稳定运行，我保留了一份内置清洗语料，同时也提供脚本重新抓取官方文档。
+这一页我还会顺着画面把这些信息讲清楚：流程：官方文档、页面抓取、正文清洗、JSONL 语料、索引构建、问答系统；每条文档包含 doc_id、title、url、text；知识主题覆盖 Redis 数据结构、TTL、持久化、高可用、集群和缓存风险。讲的时候不需要停留在单个词上，而是把它们串成“为什么这样设计、系统如何实现、结果说明什么”这条线索。</a:t>
             </a:r>
             <a:endParaRPr lang="en-US" dirty="0"/>
           </a:p>
@@ -1463,16 +1406,8 @@
           <a:p>
             <a:r>
               <a:rPr lang="en-US" dirty="0"/>
-              <a:t>第 5 页：知识库主题覆盖
-页面内容：
-基础数据结构：String、Hash、List、Stream、Sorted Set
-生命周期：EXPIRE、TTL、PERSIST
-可靠性：RDB、AOF、appendfsync
-高可用与扩展：Replication、Sentinel、Cluster
-编程与消息：事务、Lua、Pub/Sub、Stream
-缓存工程：缓存穿透、击穿和雪崩
-讲稿：
-这一页说明知识库覆盖面。Redis 不是只收集几个命令，而是覆盖了数据结构、生命周期、可靠性、高可用、编程能力和缓存工程。这样设计的好处是评估问题可以比较全面，比如既能问 AOF 和 RDB，也能问 Stream 和 Pub/Sub，或者问缓存击穿怎么缓解。覆盖原则是每个问题都应该能从知识库中找到依据。</a:t>
+              <a:t>这一页说明知识库覆盖面。Redis 不是只收集几个命令，而是覆盖了数据结构、生命周期、可靠性、高可用、编程能力和缓存工程。这样设计的好处是评估问题可以比较全面，比如既能问 AOF 和 RDB，也能问 Stream 和 Pub/Sub，或者问缓存击穿怎么缓解。覆盖原则是每个问题都应该能从知识库中找到依据，答案也要能回溯到文档来源，而不是让模型凭印象发挥。
+这一页我还会顺着画面把这些信息讲清楚：基础数据结构：String、Hash、List、Stream、Sorted Set；生命周期：EXPIRE、TTL、PERSIST；可靠性：RDB、AOF、appendfsync；高可用与扩展：Replication、Sentinel、Cluster；编程与消息：事务、Lua、Pub/Sub、Stream；缓存工程：缓存穿透、击穿和雪崩。讲的时候不需要停留在单个词上，而是把它们串成“为什么这样设计、系统如何实现、结果说明什么”这条线索。</a:t>
             </a:r>
             <a:endParaRPr lang="en-US" dirty="0"/>
           </a:p>
@@ -1560,14 +1495,8 @@
           <a:p>
             <a:r>
               <a:rPr lang="en-US" dirty="0"/>
-              <a:t>第 6 页：Chunking：让检索单元既可命中又可阅读
-页面内容：
-Redis-aware tokenizer 保留命令名、缩写和中文领域词
-默认 chunk_size=320，overlap=40
-每个 chunk 保留来源元数据
-AOF/RDB 问题需要保留持久化、persistence、RDB、AOF、snapshot 等关键 token
-讲稿：
-这一页解释 Chunking。技术文档分块不能只按普通句子切，因为 Redis 命令名非常关键。我实现了 Redis-aware tokenizer，保留命令名、缩写和中文领域词。默认分块大小是 320，重叠是 40。这样长文档可以切成可检索片段，同时相邻片段之间不会完全断开。每个 chunk 都有来源元数据，所以最后答案可以回到原文档。</a:t>
+              <a:t>这一页解释 Chunking。技术文档分块不能只按普通句子切，因为 Redis 命令名非常关键。我实现了 Redis-aware tokenizer，保留命令名、缩写和中文领域词。默认分块大小是 320，重叠是 40。这样长文档可以切成可检索片段，同时相邻片段之间不会完全断开。每个 chunk 都有来源元数据，所以最后答案可以回到原文档。
+这一页我还会顺着画面把这些信息讲清楚：Redis-aware tokenizer 保留命令名、缩写和中文领域词；默认 chunk_size=320，overlap=40；每个 chunk 保留来源元数据；AOF/RDB 问题需要保留持久化、persistence、RDB、AOF、snapshot 等关键 token。讲的时候不需要停留在单个词上，而是把它们串成“为什么这样设计、系统如何实现、结果说明什么”这条线索。</a:t>
             </a:r>
             <a:endParaRPr lang="en-US" dirty="0"/>
           </a:p>
@@ -1655,14 +1584,8 @@
           <a:p>
             <a:r>
               <a:rPr lang="en-US" dirty="0"/>
-              <a:t>第 7 页：Embedding 与本地向量数据库
-页面内容：
-默认使用 HashingEmbeddingModel，维度 256
-向量库保存 chunk 和 vector，文件是 data/index/vectors.jsonl
-优点是可复现、无需下载模型、便于解释
-后续可升级为 BGE、E5、SentenceTransformer、FAISS 或 Chroma
-讲稿：
-这一页说明 embedding 和向量库。为了保证作业在没有 GPU、没有外部模型下载的环境中也能跑，我默认使用 hashing embedding。它不如 BGE 这类模型强，但非常适合课程复现。向量库用 JSONL 保存，每条记录包含 chunk 和 vector，结构完全透明。后续如果要做真实系统，可以把这一层替换成 BGE embedding 和 FAISS 或 Chroma。</a:t>
+              <a:t>这一页说明 embedding 和向量库。为了保证作业在没有 GPU、没有外部模型下载的环境中也能跑，我默认使用 hashing embedding。它不如 BGE 这类模型强，但非常适合课程复现。向量库用 JSONL 保存，每条记录包含 chunk 和 vector，结构完全透明。后续如果要做真实系统，可以把这一层替换成 BGE embedding 和 FAISS 或 Chroma。
+这一页我还会顺着画面把这些信息讲清楚：默认使用 HashingEmbeddingModel，维度 256；向量库保存 chunk 和 vector，文件是 data/index/vectors.jsonl；优点是可复现、无需下载模型、便于解释；后续可升级为 BGE、E5、SentenceTransformer、FAISS 或 Chroma。讲的时候不需要停留在单个词上，而是把它们串成“为什么这样设计、系统如何实现、结果说明什么”这条线索。</a:t>
             </a:r>
             <a:endParaRPr lang="en-US" dirty="0"/>
           </a:p>
@@ -1750,15 +1673,8 @@
           <a:p>
             <a:r>
               <a:rPr lang="en-US" dirty="0"/>
-              <a:t>第 8 页：Query Rewriting：连接中文问题与英文术语
-页面内容：
-持久化扩展为 persistence、RDB、AOF、snapshot
-高可用扩展为 replication、sentinel、failover、cluster
-过期扩展为 expire、TTL、timeout
-队列扩展为 list、stream、consumer group、XREADGROUP
-Query Rewriting 主要提升召回率
-讲稿：
-这一页是高级 RAG 优化的第一部分：Query Rewriting。Redis 官方文档很多术语是英文，但用户可能用中文问，比如“持久化”“高可用”“过期”。如果不扩展，检索可能找不到相关英文术语。所以我维护了一个领域词表，把中文问题扩展成 Redis 常用英文概念。这个策略主要提升召回率。</a:t>
+              <a:t>这一页是高级 RAG 优化的第一部分：Query Rewriting。Redis 官方文档很多术语是英文，但用户可能用中文问，比如“持久化”“高可用”“过期”。如果不扩展，检索可能找不到相关英文术语。所以我维护了一个领域词表，把中文问题扩展成 Redis 常用英文概念。这个策略主要提升召回率。
+这一页我还会顺着画面把这些信息讲清楚：持久化扩展为 persistence、RDB、AOF、snapshot；高可用扩展为 replication、sentinel、failover、cluster；过期扩展为 expire、TTL、timeout；队列扩展为 list、stream、consumer group、XREADGROUP；Query Rewriting 主要提升召回率。讲的时候不需要停留在单个词上，而是把它们串成“为什么这样设计、系统如何实现、结果说明什么”这条线索。</a:t>
             </a:r>
             <a:endParaRPr lang="en-US" dirty="0"/>
           </a:p>
@@ -1846,14 +1762,8 @@
           <a:p>
             <a:r>
               <a:rPr lang="en-US" dirty="0"/>
-              <a:t>第 9 页：Hybrid Retrieval：BM25 与向量检索互补
-页面内容：
-融合公式：score = 0.45 × vector + 0.55 × BM25
-向量检索擅长语义相似
-BM25 擅长 AOF、RDB、TTL、WATCH 等精确术语
-Redis 问答需要语义理解和精确术语命中结合
-讲稿：
-这一页解释混合检索。向量检索能处理语义相似，但是对命令名未必足够敏感。BM25 对精确词非常有效，但不能很好处理同义表达。所以我把二者融合。公式里向量权重是 0.45，BM25 权重是 0.55，因为 Redis 问答中命令名非常关键。这个策略比单纯向量检索更适合 Redis 技术文档。</a:t>
+              <a:t>这一页解释混合检索。向量检索能处理语义相似，但是对命令名未必足够敏感。BM25 对精确词非常有效，但不能很好处理同义表达。所以我把二者融合。公式里向量权重是 0.45，BM25 权重是 0.55，因为 Redis 问答中命令名非常关键。这个策略比单纯向量检索更适合 Redis 技术文档。
+这一页我还会顺着画面把这些信息讲清楚：融合公式：score = 0.45 × vector + 0.55 × BM25；向量检索擅长语义相似；BM25 擅长 AOF、RDB、TTL、WATCH 等精确术语；Redis 问答需要语义理解和精确术语命中结合。讲的时候不需要停留在单个词上，而是把它们串成“为什么这样设计、系统如何实现、结果说明什么”这条线索。</a:t>
             </a:r>
             <a:endParaRPr lang="en-US" dirty="0"/>
           </a:p>
@@ -2811,841 +2721,12 @@
         </p:nvSpPr>
         <p:spPr>
           <a:xfrm>
-            <a:off x="502920" y="1234440"/>
-            <a:ext cx="1234440" cy="713232"/>
+            <a:off x="566928" y="1042416"/>
+            <a:ext cx="11045952" cy="5120640"/>
           </a:xfrm>
           <a:prstGeom prst="roundRect">
             <a:avLst>
-              <a:gd name="adj" fmla="val 4487"/>
-            </a:avLst>
-          </a:prstGeom>
-          <a:solidFill>
-            <a:srgbClr val="FFFFFF"/>
-          </a:solidFill>
-          <a:ln w="15240">
-            <a:solidFill>
-              <a:srgbClr val="D92D20"/>
-            </a:solidFill>
-            <a:prstDash val="solid"/>
-          </a:ln>
-        </p:spPr>
-      </p:sp>
-      <p:sp>
-        <p:nvSpPr>
-          <p:cNvPr id="7" name="Text 5"/>
-          <p:cNvSpPr/>
-          <p:nvPr/>
-        </p:nvSpPr>
-        <p:spPr>
-          <a:xfrm>
-            <a:off x="576072" y="1325880"/>
-            <a:ext cx="1088136" cy="530352"/>
-          </a:xfrm>
-          <a:prstGeom prst="rect">
-            <a:avLst/>
-          </a:prstGeom>
-          <a:noFill/>
-          <a:ln/>
-        </p:spPr>
-        <p:txBody>
-          <a:bodyPr wrap="square" lIns="0" tIns="0" rIns="0" bIns="0" rtlCol="0" anchor="ctr">
-            <a:normAutofit/>
-          </a:bodyPr>
-          <a:lstStyle/>
-          <a:p>
-            <a:pPr algn="ctr" indent="0" marL="0">
-              <a:buNone/>
-            </a:pPr>
-            <a:r>
-              <a:rPr lang="en-US" sz="1350" b="1" dirty="0">
-                <a:solidFill>
-                  <a:srgbClr val="17212B"/>
-                </a:solidFill>
-                <a:latin typeface="Microsoft YaHei" pitchFamily="34" charset="0"/>
-                <a:ea typeface="Microsoft YaHei" pitchFamily="34" charset="-122"/>
-                <a:cs typeface="Microsoft YaHei" pitchFamily="34" charset="-120"/>
-              </a:rPr>
-              <a:t>文档</a:t>
-            </a:r>
-            <a:endParaRPr lang="en-US" sz="1350" dirty="0"/>
-          </a:p>
-          <a:p>
-            <a:pPr algn="ctr" indent="0" marL="0">
-              <a:buNone/>
-            </a:pPr>
-            <a:r>
-              <a:rPr lang="en-US" sz="1350" b="1" dirty="0">
-                <a:solidFill>
-                  <a:srgbClr val="17212B"/>
-                </a:solidFill>
-                <a:latin typeface="Microsoft YaHei" pitchFamily="34" charset="0"/>
-                <a:ea typeface="Microsoft YaHei" pitchFamily="34" charset="-122"/>
-                <a:cs typeface="Microsoft YaHei" pitchFamily="34" charset="-120"/>
-              </a:rPr>
-              <a:t>JSONL</a:t>
-            </a:r>
-            <a:endParaRPr lang="en-US" sz="1350" dirty="0"/>
-          </a:p>
-        </p:txBody>
-      </p:sp>
-      <p:sp>
-        <p:nvSpPr>
-          <p:cNvPr id="8" name="Shape 6"/>
-          <p:cNvSpPr/>
-          <p:nvPr/>
-        </p:nvSpPr>
-        <p:spPr>
-          <a:xfrm>
-            <a:off x="1783080" y="1591056"/>
-            <a:ext cx="320040" cy="0"/>
-          </a:xfrm>
-          <a:prstGeom prst="line">
-            <a:avLst/>
-          </a:prstGeom>
-          <a:noFill/>
-          <a:ln w="17780">
-            <a:solidFill>
-              <a:srgbClr val="D92D20"/>
-            </a:solidFill>
-            <a:prstDash val="solid"/>
-            <a:headEnd type="none"/>
-            <a:tailEnd type="triangle"/>
-          </a:ln>
-        </p:spPr>
-      </p:sp>
-      <p:sp>
-        <p:nvSpPr>
-          <p:cNvPr id="9" name="Shape 7"/>
-          <p:cNvSpPr/>
-          <p:nvPr/>
-        </p:nvSpPr>
-        <p:spPr>
-          <a:xfrm>
-            <a:off x="2103120" y="1234440"/>
-            <a:ext cx="1325880" cy="713232"/>
-          </a:xfrm>
-          <a:prstGeom prst="roundRect">
-            <a:avLst>
-              <a:gd name="adj" fmla="val 4487"/>
-            </a:avLst>
-          </a:prstGeom>
-          <a:solidFill>
-            <a:srgbClr val="FDE8E5"/>
-          </a:solidFill>
-          <a:ln w="15240">
-            <a:solidFill>
-              <a:srgbClr val="D92D20"/>
-            </a:solidFill>
-            <a:prstDash val="solid"/>
-          </a:ln>
-        </p:spPr>
-      </p:sp>
-      <p:sp>
-        <p:nvSpPr>
-          <p:cNvPr id="10" name="Text 8"/>
-          <p:cNvSpPr/>
-          <p:nvPr/>
-        </p:nvSpPr>
-        <p:spPr>
-          <a:xfrm>
-            <a:off x="2176272" y="1325880"/>
-            <a:ext cx="1179576" cy="530352"/>
-          </a:xfrm>
-          <a:prstGeom prst="rect">
-            <a:avLst/>
-          </a:prstGeom>
-          <a:noFill/>
-          <a:ln/>
-        </p:spPr>
-        <p:txBody>
-          <a:bodyPr wrap="square" lIns="0" tIns="0" rIns="0" bIns="0" rtlCol="0" anchor="ctr">
-            <a:normAutofit/>
-          </a:bodyPr>
-          <a:lstStyle/>
-          <a:p>
-            <a:pPr algn="ctr" indent="0" marL="0">
-              <a:buNone/>
-            </a:pPr>
-            <a:r>
-              <a:rPr lang="en-US" sz="1350" b="1" dirty="0">
-                <a:solidFill>
-                  <a:srgbClr val="17212B"/>
-                </a:solidFill>
-                <a:latin typeface="Microsoft YaHei" pitchFamily="34" charset="0"/>
-                <a:ea typeface="Microsoft YaHei" pitchFamily="34" charset="-122"/>
-                <a:cs typeface="Microsoft YaHei" pitchFamily="34" charset="-120"/>
-              </a:rPr>
-              <a:t>Chunking</a:t>
-            </a:r>
-            <a:endParaRPr lang="en-US" sz="1350" dirty="0"/>
-          </a:p>
-        </p:txBody>
-      </p:sp>
-      <p:sp>
-        <p:nvSpPr>
-          <p:cNvPr id="11" name="Shape 9"/>
-          <p:cNvSpPr/>
-          <p:nvPr/>
-        </p:nvSpPr>
-        <p:spPr>
-          <a:xfrm>
-            <a:off x="3474720" y="1591056"/>
-            <a:ext cx="320040" cy="-420624"/>
-          </a:xfrm>
-          <a:prstGeom prst="line">
-            <a:avLst/>
-          </a:prstGeom>
-          <a:noFill/>
-          <a:ln w="17780">
-            <a:solidFill>
-              <a:srgbClr val="D92D20"/>
-            </a:solidFill>
-            <a:prstDash val="solid"/>
-            <a:headEnd type="none"/>
-            <a:tailEnd type="triangle"/>
-          </a:ln>
-        </p:spPr>
-      </p:sp>
-      <p:sp>
-        <p:nvSpPr>
-          <p:cNvPr id="12" name="Shape 10"/>
-          <p:cNvSpPr/>
-          <p:nvPr/>
-        </p:nvSpPr>
-        <p:spPr>
-          <a:xfrm>
-            <a:off x="3474720" y="1591056"/>
-            <a:ext cx="320040" cy="402336"/>
-          </a:xfrm>
-          <a:prstGeom prst="line">
-            <a:avLst/>
-          </a:prstGeom>
-          <a:noFill/>
-          <a:ln w="17780">
-            <a:solidFill>
-              <a:srgbClr val="D92D20"/>
-            </a:solidFill>
-            <a:prstDash val="solid"/>
-            <a:headEnd type="none"/>
-            <a:tailEnd type="triangle"/>
-          </a:ln>
-        </p:spPr>
-      </p:sp>
-      <p:sp>
-        <p:nvSpPr>
-          <p:cNvPr id="13" name="Shape 11"/>
-          <p:cNvSpPr/>
-          <p:nvPr/>
-        </p:nvSpPr>
-        <p:spPr>
-          <a:xfrm>
-            <a:off x="3794760" y="804672"/>
-            <a:ext cx="1325880" cy="658368"/>
-          </a:xfrm>
-          <a:prstGeom prst="roundRect">
-            <a:avLst>
-              <a:gd name="adj" fmla="val 4861"/>
-            </a:avLst>
-          </a:prstGeom>
-          <a:solidFill>
-            <a:srgbClr val="EAF2FF"/>
-          </a:solidFill>
-          <a:ln w="15240">
-            <a:solidFill>
-              <a:srgbClr val="2563EB"/>
-            </a:solidFill>
-            <a:prstDash val="solid"/>
-          </a:ln>
-        </p:spPr>
-      </p:sp>
-      <p:sp>
-        <p:nvSpPr>
-          <p:cNvPr id="14" name="Text 12"/>
-          <p:cNvSpPr/>
-          <p:nvPr/>
-        </p:nvSpPr>
-        <p:spPr>
-          <a:xfrm>
-            <a:off x="3867912" y="896112"/>
-            <a:ext cx="1179576" cy="475488"/>
-          </a:xfrm>
-          <a:prstGeom prst="rect">
-            <a:avLst/>
-          </a:prstGeom>
-          <a:noFill/>
-          <a:ln/>
-        </p:spPr>
-        <p:txBody>
-          <a:bodyPr wrap="square" lIns="0" tIns="0" rIns="0" bIns="0" rtlCol="0" anchor="ctr">
-            <a:normAutofit/>
-          </a:bodyPr>
-          <a:lstStyle/>
-          <a:p>
-            <a:pPr algn="ctr" indent="0" marL="0">
-              <a:buNone/>
-            </a:pPr>
-            <a:r>
-              <a:rPr lang="en-US" sz="1350" b="1" dirty="0">
-                <a:solidFill>
-                  <a:srgbClr val="17212B"/>
-                </a:solidFill>
-                <a:latin typeface="Microsoft YaHei" pitchFamily="34" charset="0"/>
-                <a:ea typeface="Microsoft YaHei" pitchFamily="34" charset="-122"/>
-                <a:cs typeface="Microsoft YaHei" pitchFamily="34" charset="-120"/>
-              </a:rPr>
-              <a:t>Embedding</a:t>
-            </a:r>
-            <a:endParaRPr lang="en-US" sz="1350" dirty="0"/>
-          </a:p>
-        </p:txBody>
-      </p:sp>
-      <p:sp>
-        <p:nvSpPr>
-          <p:cNvPr id="15" name="Shape 13"/>
-          <p:cNvSpPr/>
-          <p:nvPr/>
-        </p:nvSpPr>
-        <p:spPr>
-          <a:xfrm>
-            <a:off x="3794760" y="1645920"/>
-            <a:ext cx="1325880" cy="658368"/>
-          </a:xfrm>
-          <a:prstGeom prst="roundRect">
-            <a:avLst>
-              <a:gd name="adj" fmla="val 4861"/>
-            </a:avLst>
-          </a:prstGeom>
-          <a:solidFill>
-            <a:srgbClr val="E9F8F4"/>
-          </a:solidFill>
-          <a:ln w="15240">
-            <a:solidFill>
-              <a:srgbClr val="0F766E"/>
-            </a:solidFill>
-            <a:prstDash val="solid"/>
-          </a:ln>
-        </p:spPr>
-      </p:sp>
-      <p:sp>
-        <p:nvSpPr>
-          <p:cNvPr id="16" name="Text 14"/>
-          <p:cNvSpPr/>
-          <p:nvPr/>
-        </p:nvSpPr>
-        <p:spPr>
-          <a:xfrm>
-            <a:off x="3867912" y="1737360"/>
-            <a:ext cx="1179576" cy="475488"/>
-          </a:xfrm>
-          <a:prstGeom prst="rect">
-            <a:avLst/>
-          </a:prstGeom>
-          <a:noFill/>
-          <a:ln/>
-        </p:spPr>
-        <p:txBody>
-          <a:bodyPr wrap="square" lIns="0" tIns="0" rIns="0" bIns="0" rtlCol="0" anchor="ctr">
-            <a:normAutofit/>
-          </a:bodyPr>
-          <a:lstStyle/>
-          <a:p>
-            <a:pPr algn="ctr" indent="0" marL="0">
-              <a:buNone/>
-            </a:pPr>
-            <a:r>
-              <a:rPr lang="en-US" sz="1350" b="1" dirty="0">
-                <a:solidFill>
-                  <a:srgbClr val="17212B"/>
-                </a:solidFill>
-                <a:latin typeface="Microsoft YaHei" pitchFamily="34" charset="0"/>
-                <a:ea typeface="Microsoft YaHei" pitchFamily="34" charset="-122"/>
-                <a:cs typeface="Microsoft YaHei" pitchFamily="34" charset="-120"/>
-              </a:rPr>
-              <a:t>BM25</a:t>
-            </a:r>
-            <a:endParaRPr lang="en-US" sz="1350" dirty="0"/>
-          </a:p>
-        </p:txBody>
-      </p:sp>
-      <p:sp>
-        <p:nvSpPr>
-          <p:cNvPr id="17" name="Shape 15"/>
-          <p:cNvSpPr/>
-          <p:nvPr/>
-        </p:nvSpPr>
-        <p:spPr>
-          <a:xfrm>
-            <a:off x="5166360" y="1133856"/>
-            <a:ext cx="502920" cy="347472"/>
-          </a:xfrm>
-          <a:prstGeom prst="line">
-            <a:avLst/>
-          </a:prstGeom>
-          <a:noFill/>
-          <a:ln w="17780">
-            <a:solidFill>
-              <a:srgbClr val="D92D20"/>
-            </a:solidFill>
-            <a:prstDash val="solid"/>
-            <a:headEnd type="none"/>
-            <a:tailEnd type="triangle"/>
-          </a:ln>
-        </p:spPr>
-      </p:sp>
-      <p:sp>
-        <p:nvSpPr>
-          <p:cNvPr id="18" name="Shape 16"/>
-          <p:cNvSpPr/>
-          <p:nvPr/>
-        </p:nvSpPr>
-        <p:spPr>
-          <a:xfrm>
-            <a:off x="5166360" y="1975104"/>
-            <a:ext cx="502920" cy="-237744"/>
-          </a:xfrm>
-          <a:prstGeom prst="line">
-            <a:avLst/>
-          </a:prstGeom>
-          <a:noFill/>
-          <a:ln w="17780">
-            <a:solidFill>
-              <a:srgbClr val="D92D20"/>
-            </a:solidFill>
-            <a:prstDash val="solid"/>
-            <a:headEnd type="none"/>
-            <a:tailEnd type="triangle"/>
-          </a:ln>
-        </p:spPr>
-      </p:sp>
-      <p:sp>
-        <p:nvSpPr>
-          <p:cNvPr id="19" name="Shape 17"/>
-          <p:cNvSpPr/>
-          <p:nvPr/>
-        </p:nvSpPr>
-        <p:spPr>
-          <a:xfrm>
-            <a:off x="5669280" y="1234440"/>
-            <a:ext cx="1508760" cy="713232"/>
-          </a:xfrm>
-          <a:prstGeom prst="roundRect">
-            <a:avLst>
-              <a:gd name="adj" fmla="val 4487"/>
-            </a:avLst>
-          </a:prstGeom>
-          <a:solidFill>
-            <a:srgbClr val="FFFFFF"/>
-          </a:solidFill>
-          <a:ln w="15240">
-            <a:solidFill>
-              <a:srgbClr val="D92D20"/>
-            </a:solidFill>
-            <a:prstDash val="solid"/>
-          </a:ln>
-        </p:spPr>
-      </p:sp>
-      <p:sp>
-        <p:nvSpPr>
-          <p:cNvPr id="20" name="Text 18"/>
-          <p:cNvSpPr/>
-          <p:nvPr/>
-        </p:nvSpPr>
-        <p:spPr>
-          <a:xfrm>
-            <a:off x="5742432" y="1325880"/>
-            <a:ext cx="1362456" cy="530352"/>
-          </a:xfrm>
-          <a:prstGeom prst="rect">
-            <a:avLst/>
-          </a:prstGeom>
-          <a:noFill/>
-          <a:ln/>
-        </p:spPr>
-        <p:txBody>
-          <a:bodyPr wrap="square" lIns="0" tIns="0" rIns="0" bIns="0" rtlCol="0" anchor="ctr">
-            <a:normAutofit/>
-          </a:bodyPr>
-          <a:lstStyle/>
-          <a:p>
-            <a:pPr algn="ctr" indent="0" marL="0">
-              <a:buNone/>
-            </a:pPr>
-            <a:r>
-              <a:rPr lang="en-US" sz="1350" b="1" dirty="0">
-                <a:solidFill>
-                  <a:srgbClr val="17212B"/>
-                </a:solidFill>
-                <a:latin typeface="Microsoft YaHei" pitchFamily="34" charset="0"/>
-                <a:ea typeface="Microsoft YaHei" pitchFamily="34" charset="-122"/>
-                <a:cs typeface="Microsoft YaHei" pitchFamily="34" charset="-120"/>
-              </a:rPr>
-              <a:t>Hybrid</a:t>
-            </a:r>
-            <a:endParaRPr lang="en-US" sz="1350" dirty="0"/>
-          </a:p>
-          <a:p>
-            <a:pPr algn="ctr" indent="0" marL="0">
-              <a:buNone/>
-            </a:pPr>
-            <a:r>
-              <a:rPr lang="en-US" sz="1350" b="1" dirty="0">
-                <a:solidFill>
-                  <a:srgbClr val="17212B"/>
-                </a:solidFill>
-                <a:latin typeface="Microsoft YaHei" pitchFamily="34" charset="0"/>
-                <a:ea typeface="Microsoft YaHei" pitchFamily="34" charset="-122"/>
-                <a:cs typeface="Microsoft YaHei" pitchFamily="34" charset="-120"/>
-              </a:rPr>
-              <a:t>Retriever</a:t>
-            </a:r>
-            <a:endParaRPr lang="en-US" sz="1350" dirty="0"/>
-          </a:p>
-        </p:txBody>
-      </p:sp>
-      <p:sp>
-        <p:nvSpPr>
-          <p:cNvPr id="21" name="Shape 19"/>
-          <p:cNvSpPr/>
-          <p:nvPr/>
-        </p:nvSpPr>
-        <p:spPr>
-          <a:xfrm>
-            <a:off x="7223760" y="1591056"/>
-            <a:ext cx="320040" cy="0"/>
-          </a:xfrm>
-          <a:prstGeom prst="line">
-            <a:avLst/>
-          </a:prstGeom>
-          <a:noFill/>
-          <a:ln w="17780">
-            <a:solidFill>
-              <a:srgbClr val="D92D20"/>
-            </a:solidFill>
-            <a:prstDash val="solid"/>
-            <a:headEnd type="none"/>
-            <a:tailEnd type="triangle"/>
-          </a:ln>
-        </p:spPr>
-      </p:sp>
-      <p:sp>
-        <p:nvSpPr>
-          <p:cNvPr id="22" name="Shape 20"/>
-          <p:cNvSpPr/>
-          <p:nvPr/>
-        </p:nvSpPr>
-        <p:spPr>
-          <a:xfrm>
-            <a:off x="7543800" y="1234440"/>
-            <a:ext cx="1325880" cy="713232"/>
-          </a:xfrm>
-          <a:prstGeom prst="roundRect">
-            <a:avLst>
-              <a:gd name="adj" fmla="val 4487"/>
-            </a:avLst>
-          </a:prstGeom>
-          <a:solidFill>
-            <a:srgbClr val="FDE8E5"/>
-          </a:solidFill>
-          <a:ln w="15240">
-            <a:solidFill>
-              <a:srgbClr val="D92D20"/>
-            </a:solidFill>
-            <a:prstDash val="solid"/>
-          </a:ln>
-        </p:spPr>
-      </p:sp>
-      <p:sp>
-        <p:nvSpPr>
-          <p:cNvPr id="23" name="Text 21"/>
-          <p:cNvSpPr/>
-          <p:nvPr/>
-        </p:nvSpPr>
-        <p:spPr>
-          <a:xfrm>
-            <a:off x="7616952" y="1325880"/>
-            <a:ext cx="1179576" cy="530352"/>
-          </a:xfrm>
-          <a:prstGeom prst="rect">
-            <a:avLst/>
-          </a:prstGeom>
-          <a:noFill/>
-          <a:ln/>
-        </p:spPr>
-        <p:txBody>
-          <a:bodyPr wrap="square" lIns="0" tIns="0" rIns="0" bIns="0" rtlCol="0" anchor="ctr">
-            <a:normAutofit/>
-          </a:bodyPr>
-          <a:lstStyle/>
-          <a:p>
-            <a:pPr algn="ctr" indent="0" marL="0">
-              <a:buNone/>
-            </a:pPr>
-            <a:r>
-              <a:rPr lang="en-US" sz="1350" b="1" dirty="0">
-                <a:solidFill>
-                  <a:srgbClr val="17212B"/>
-                </a:solidFill>
-                <a:latin typeface="Microsoft YaHei" pitchFamily="34" charset="0"/>
-                <a:ea typeface="Microsoft YaHei" pitchFamily="34" charset="-122"/>
-                <a:cs typeface="Microsoft YaHei" pitchFamily="34" charset="-120"/>
-              </a:rPr>
-              <a:t>Top-k</a:t>
-            </a:r>
-            <a:endParaRPr lang="en-US" sz="1350" dirty="0"/>
-          </a:p>
-          <a:p>
-            <a:pPr algn="ctr" indent="0" marL="0">
-              <a:buNone/>
-            </a:pPr>
-            <a:r>
-              <a:rPr lang="en-US" sz="1350" b="1" dirty="0">
-                <a:solidFill>
-                  <a:srgbClr val="17212B"/>
-                </a:solidFill>
-                <a:latin typeface="Microsoft YaHei" pitchFamily="34" charset="0"/>
-                <a:ea typeface="Microsoft YaHei" pitchFamily="34" charset="-122"/>
-                <a:cs typeface="Microsoft YaHei" pitchFamily="34" charset="-120"/>
-              </a:rPr>
-              <a:t>Contexts</a:t>
-            </a:r>
-            <a:endParaRPr lang="en-US" sz="1350" dirty="0"/>
-          </a:p>
-        </p:txBody>
-      </p:sp>
-      <p:sp>
-        <p:nvSpPr>
-          <p:cNvPr id="24" name="Shape 22"/>
-          <p:cNvSpPr/>
-          <p:nvPr/>
-        </p:nvSpPr>
-        <p:spPr>
-          <a:xfrm>
-            <a:off x="8915400" y="1591056"/>
-            <a:ext cx="320040" cy="0"/>
-          </a:xfrm>
-          <a:prstGeom prst="line">
-            <a:avLst/>
-          </a:prstGeom>
-          <a:noFill/>
-          <a:ln w="17780">
-            <a:solidFill>
-              <a:srgbClr val="D92D20"/>
-            </a:solidFill>
-            <a:prstDash val="solid"/>
-            <a:headEnd type="none"/>
-            <a:tailEnd type="triangle"/>
-          </a:ln>
-        </p:spPr>
-      </p:sp>
-      <p:sp>
-        <p:nvSpPr>
-          <p:cNvPr id="25" name="Shape 23"/>
-          <p:cNvSpPr/>
-          <p:nvPr/>
-        </p:nvSpPr>
-        <p:spPr>
-          <a:xfrm>
-            <a:off x="9235440" y="1234440"/>
-            <a:ext cx="1508760" cy="713232"/>
-          </a:xfrm>
-          <a:prstGeom prst="roundRect">
-            <a:avLst>
-              <a:gd name="adj" fmla="val 4487"/>
-            </a:avLst>
-          </a:prstGeom>
-          <a:solidFill>
-            <a:srgbClr val="EAF2FF"/>
-          </a:solidFill>
-          <a:ln w="15240">
-            <a:solidFill>
-              <a:srgbClr val="2563EB"/>
-            </a:solidFill>
-            <a:prstDash val="solid"/>
-          </a:ln>
-        </p:spPr>
-      </p:sp>
-      <p:sp>
-        <p:nvSpPr>
-          <p:cNvPr id="26" name="Text 24"/>
-          <p:cNvSpPr/>
-          <p:nvPr/>
-        </p:nvSpPr>
-        <p:spPr>
-          <a:xfrm>
-            <a:off x="9308592" y="1325880"/>
-            <a:ext cx="1362456" cy="530352"/>
-          </a:xfrm>
-          <a:prstGeom prst="rect">
-            <a:avLst/>
-          </a:prstGeom>
-          <a:noFill/>
-          <a:ln/>
-        </p:spPr>
-        <p:txBody>
-          <a:bodyPr wrap="square" lIns="0" tIns="0" rIns="0" bIns="0" rtlCol="0" anchor="ctr">
-            <a:normAutofit/>
-          </a:bodyPr>
-          <a:lstStyle/>
-          <a:p>
-            <a:pPr algn="ctr" indent="0" marL="0">
-              <a:buNone/>
-            </a:pPr>
-            <a:r>
-              <a:rPr lang="en-US" sz="1350" b="1" dirty="0">
-                <a:solidFill>
-                  <a:srgbClr val="17212B"/>
-                </a:solidFill>
-                <a:latin typeface="Microsoft YaHei" pitchFamily="34" charset="0"/>
-                <a:ea typeface="Microsoft YaHei" pitchFamily="34" charset="-122"/>
-                <a:cs typeface="Microsoft YaHei" pitchFamily="34" charset="-120"/>
-              </a:rPr>
-              <a:t>DeepSeek /</a:t>
-            </a:r>
-            <a:endParaRPr lang="en-US" sz="1350" dirty="0"/>
-          </a:p>
-          <a:p>
-            <a:pPr algn="ctr" indent="0" marL="0">
-              <a:buNone/>
-            </a:pPr>
-            <a:r>
-              <a:rPr lang="en-US" sz="1350" b="1" dirty="0">
-                <a:solidFill>
-                  <a:srgbClr val="17212B"/>
-                </a:solidFill>
-                <a:latin typeface="Microsoft YaHei" pitchFamily="34" charset="0"/>
-                <a:ea typeface="Microsoft YaHei" pitchFamily="34" charset="-122"/>
-                <a:cs typeface="Microsoft YaHei" pitchFamily="34" charset="-120"/>
-              </a:rPr>
-              <a:t>Fallback</a:t>
-            </a:r>
-            <a:endParaRPr lang="en-US" sz="1350" dirty="0"/>
-          </a:p>
-        </p:txBody>
-      </p:sp>
-      <p:sp>
-        <p:nvSpPr>
-          <p:cNvPr id="27" name="Shape 25"/>
-          <p:cNvSpPr/>
-          <p:nvPr/>
-        </p:nvSpPr>
-        <p:spPr>
-          <a:xfrm>
-            <a:off x="10789920" y="1591056"/>
-            <a:ext cx="320040" cy="0"/>
-          </a:xfrm>
-          <a:prstGeom prst="line">
-            <a:avLst/>
-          </a:prstGeom>
-          <a:noFill/>
-          <a:ln w="17780">
-            <a:solidFill>
-              <a:srgbClr val="D92D20"/>
-            </a:solidFill>
-            <a:prstDash val="solid"/>
-            <a:headEnd type="none"/>
-            <a:tailEnd type="triangle"/>
-          </a:ln>
-        </p:spPr>
-      </p:sp>
-      <p:sp>
-        <p:nvSpPr>
-          <p:cNvPr id="28" name="Shape 26"/>
-          <p:cNvSpPr/>
-          <p:nvPr/>
-        </p:nvSpPr>
-        <p:spPr>
-          <a:xfrm>
-            <a:off x="11109960" y="1234440"/>
-            <a:ext cx="822960" cy="713232"/>
-          </a:xfrm>
-          <a:prstGeom prst="roundRect">
-            <a:avLst>
-              <a:gd name="adj" fmla="val 4487"/>
-            </a:avLst>
-          </a:prstGeom>
-          <a:solidFill>
-            <a:srgbClr val="FFFFFF"/>
-          </a:solidFill>
-          <a:ln w="15240">
-            <a:solidFill>
-              <a:srgbClr val="D92D20"/>
-            </a:solidFill>
-            <a:prstDash val="solid"/>
-          </a:ln>
-        </p:spPr>
-      </p:sp>
-      <p:sp>
-        <p:nvSpPr>
-          <p:cNvPr id="29" name="Text 27"/>
-          <p:cNvSpPr/>
-          <p:nvPr/>
-        </p:nvSpPr>
-        <p:spPr>
-          <a:xfrm>
-            <a:off x="11183112" y="1325880"/>
-            <a:ext cx="676656" cy="530352"/>
-          </a:xfrm>
-          <a:prstGeom prst="rect">
-            <a:avLst/>
-          </a:prstGeom>
-          <a:noFill/>
-          <a:ln/>
-        </p:spPr>
-        <p:txBody>
-          <a:bodyPr wrap="square" lIns="0" tIns="0" rIns="0" bIns="0" rtlCol="0" anchor="ctr">
-            <a:normAutofit/>
-          </a:bodyPr>
-          <a:lstStyle/>
-          <a:p>
-            <a:pPr algn="ctr" indent="0" marL="0">
-              <a:buNone/>
-            </a:pPr>
-            <a:r>
-              <a:rPr lang="en-US" sz="1350" b="1" dirty="0">
-                <a:solidFill>
-                  <a:srgbClr val="17212B"/>
-                </a:solidFill>
-                <a:latin typeface="Microsoft YaHei" pitchFamily="34" charset="0"/>
-                <a:ea typeface="Microsoft YaHei" pitchFamily="34" charset="-122"/>
-                <a:cs typeface="Microsoft YaHei" pitchFamily="34" charset="-120"/>
-              </a:rPr>
-              <a:t>带引用</a:t>
-            </a:r>
-            <a:endParaRPr lang="en-US" sz="1350" dirty="0"/>
-          </a:p>
-          <a:p>
-            <a:pPr algn="ctr" indent="0" marL="0">
-              <a:buNone/>
-            </a:pPr>
-            <a:r>
-              <a:rPr lang="en-US" sz="1350" b="1" dirty="0">
-                <a:solidFill>
-                  <a:srgbClr val="17212B"/>
-                </a:solidFill>
-                <a:latin typeface="Microsoft YaHei" pitchFamily="34" charset="0"/>
-                <a:ea typeface="Microsoft YaHei" pitchFamily="34" charset="-122"/>
-                <a:cs typeface="Microsoft YaHei" pitchFamily="34" charset="-120"/>
-              </a:rPr>
-              <a:t>答案</a:t>
-            </a:r>
-            <a:endParaRPr lang="en-US" sz="1350" dirty="0"/>
-          </a:p>
-        </p:txBody>
-      </p:sp>
-      <p:sp>
-        <p:nvSpPr>
-          <p:cNvPr id="30" name="Shape 28"/>
-          <p:cNvSpPr/>
-          <p:nvPr/>
-        </p:nvSpPr>
-        <p:spPr>
-          <a:xfrm>
-            <a:off x="777240" y="3154680"/>
-            <a:ext cx="3383280" cy="1417320"/>
-          </a:xfrm>
-          <a:prstGeom prst="roundRect">
-            <a:avLst>
-              <a:gd name="adj" fmla="val 2903"/>
+              <a:gd name="adj" fmla="val 714"/>
             </a:avLst>
           </a:prstGeom>
           <a:solidFill>
@@ -3657,434 +2738,11 @@
             </a:solidFill>
             <a:prstDash val="solid"/>
           </a:ln>
-          <a:effectLst>
-            <a:outerShdw sx="100000" sy="100000" kx="0" ky="0" algn="bl" rotWithShape="0" blurRad="12700" dist="50800" dir="2700000">
-              <a:srgbClr val="D7DEE8">
-                <a:alpha val="18000"/>
-              </a:srgbClr>
-            </a:outerShdw>
-          </a:effectLst>
-        </p:spPr>
-      </p:sp>
-      <p:sp>
-        <p:nvSpPr>
-          <p:cNvPr id="31" name="Shape 29"/>
-          <p:cNvSpPr/>
-          <p:nvPr/>
-        </p:nvSpPr>
-        <p:spPr>
-          <a:xfrm>
-            <a:off x="777240" y="3154680"/>
-            <a:ext cx="91440" cy="1417320"/>
-          </a:xfrm>
-          <a:prstGeom prst="rect">
-            <a:avLst/>
-          </a:prstGeom>
-          <a:solidFill>
-            <a:srgbClr val="D92D20"/>
-          </a:solidFill>
-          <a:ln w="12700">
-            <a:solidFill>
-              <a:srgbClr val="D92D20"/>
-            </a:solidFill>
-            <a:prstDash val="solid"/>
-          </a:ln>
-        </p:spPr>
-      </p:sp>
-      <p:sp>
-        <p:nvSpPr>
-          <p:cNvPr id="32" name="Text 30"/>
-          <p:cNvSpPr/>
-          <p:nvPr/>
-        </p:nvSpPr>
-        <p:spPr>
-          <a:xfrm>
-            <a:off x="1014984" y="3319272"/>
-            <a:ext cx="2999232" cy="256032"/>
-          </a:xfrm>
-          <a:prstGeom prst="rect">
-            <a:avLst/>
-          </a:prstGeom>
-          <a:noFill/>
-          <a:ln/>
-        </p:spPr>
-        <p:txBody>
-          <a:bodyPr wrap="square" lIns="0" tIns="0" rIns="0" bIns="0" rtlCol="0" anchor="ctr">
-            <a:normAutofit/>
-          </a:bodyPr>
-          <a:lstStyle/>
-          <a:p>
-            <a:pPr indent="0" marL="0">
-              <a:buNone/>
-            </a:pPr>
-            <a:r>
-              <a:rPr lang="en-US" sz="1600" b="1" dirty="0">
-                <a:solidFill>
-                  <a:srgbClr val="17212B"/>
-                </a:solidFill>
-                <a:latin typeface="Microsoft YaHei" pitchFamily="34" charset="0"/>
-                <a:ea typeface="Microsoft YaHei" pitchFamily="34" charset="-122"/>
-                <a:cs typeface="Microsoft YaHei" pitchFamily="34" charset="-120"/>
-              </a:rPr>
-              <a:t>可观测</a:t>
-            </a:r>
-            <a:endParaRPr lang="en-US" sz="1600" dirty="0"/>
-          </a:p>
-        </p:txBody>
-      </p:sp>
-      <p:sp>
-        <p:nvSpPr>
-          <p:cNvPr id="33" name="Text 31"/>
-          <p:cNvSpPr/>
-          <p:nvPr/>
-        </p:nvSpPr>
-        <p:spPr>
-          <a:xfrm>
-            <a:off x="1014984" y="3721608"/>
-            <a:ext cx="2999232" cy="704088"/>
-          </a:xfrm>
-          <a:prstGeom prst="rect">
-            <a:avLst/>
-          </a:prstGeom>
-          <a:noFill/>
-          <a:ln/>
-        </p:spPr>
-        <p:txBody>
-          <a:bodyPr wrap="square" lIns="0" tIns="0" rIns="0" bIns="0" rtlCol="0" anchor="t">
-            <a:normAutofit/>
-          </a:bodyPr>
-          <a:lstStyle/>
-          <a:p>
-            <a:pPr indent="0" marL="0">
-              <a:buNone/>
-            </a:pPr>
-            <a:r>
-              <a:rPr lang="en-US" sz="1380" dirty="0">
-                <a:solidFill>
-                  <a:srgbClr val="24313D"/>
-                </a:solidFill>
-                <a:latin typeface="Microsoft YaHei" pitchFamily="34" charset="0"/>
-                <a:ea typeface="Microsoft YaHei" pitchFamily="34" charset="-122"/>
-                <a:cs typeface="Microsoft YaHei" pitchFamily="34" charset="-120"/>
-              </a:rPr>
-              <a:t>输出 retrieved_contexts，展示 doc_id、title、combined_score、vector_score 和 bm25_score。</a:t>
-            </a:r>
-            <a:endParaRPr lang="en-US" sz="1380" dirty="0"/>
-          </a:p>
-        </p:txBody>
-      </p:sp>
-      <p:sp>
-        <p:nvSpPr>
-          <p:cNvPr id="34" name="Shape 32"/>
-          <p:cNvSpPr/>
-          <p:nvPr/>
-        </p:nvSpPr>
-        <p:spPr>
-          <a:xfrm>
-            <a:off x="4434840" y="3154680"/>
-            <a:ext cx="3383280" cy="1417320"/>
-          </a:xfrm>
-          <a:prstGeom prst="roundRect">
-            <a:avLst>
-              <a:gd name="adj" fmla="val 2903"/>
-            </a:avLst>
-          </a:prstGeom>
-          <a:solidFill>
-            <a:srgbClr val="FFFFFF"/>
-          </a:solidFill>
-          <a:ln w="12700">
-            <a:solidFill>
-              <a:srgbClr val="CBD5E1"/>
-            </a:solidFill>
-            <a:prstDash val="solid"/>
-          </a:ln>
-          <a:effectLst>
-            <a:outerShdw sx="100000" sy="100000" kx="0" ky="0" algn="bl" rotWithShape="0" blurRad="12700" dist="50800" dir="2700000">
-              <a:srgbClr val="D7DEE8">
-                <a:alpha val="18000"/>
-              </a:srgbClr>
-            </a:outerShdw>
-          </a:effectLst>
-        </p:spPr>
-      </p:sp>
-      <p:sp>
-        <p:nvSpPr>
-          <p:cNvPr id="35" name="Shape 33"/>
-          <p:cNvSpPr/>
-          <p:nvPr/>
-        </p:nvSpPr>
-        <p:spPr>
-          <a:xfrm>
-            <a:off x="4434840" y="3154680"/>
-            <a:ext cx="91440" cy="1417320"/>
-          </a:xfrm>
-          <a:prstGeom prst="rect">
-            <a:avLst/>
-          </a:prstGeom>
-          <a:solidFill>
-            <a:srgbClr val="0F766E"/>
-          </a:solidFill>
-          <a:ln w="12700">
-            <a:solidFill>
-              <a:srgbClr val="0F766E"/>
-            </a:solidFill>
-            <a:prstDash val="solid"/>
-          </a:ln>
-        </p:spPr>
-      </p:sp>
-      <p:sp>
-        <p:nvSpPr>
-          <p:cNvPr id="36" name="Text 34"/>
-          <p:cNvSpPr/>
-          <p:nvPr/>
-        </p:nvSpPr>
-        <p:spPr>
-          <a:xfrm>
-            <a:off x="4672584" y="3319272"/>
-            <a:ext cx="2999232" cy="256032"/>
-          </a:xfrm>
-          <a:prstGeom prst="rect">
-            <a:avLst/>
-          </a:prstGeom>
-          <a:noFill/>
-          <a:ln/>
-        </p:spPr>
-        <p:txBody>
-          <a:bodyPr wrap="square" lIns="0" tIns="0" rIns="0" bIns="0" rtlCol="0" anchor="ctr">
-            <a:normAutofit/>
-          </a:bodyPr>
-          <a:lstStyle/>
-          <a:p>
-            <a:pPr indent="0" marL="0">
-              <a:buNone/>
-            </a:pPr>
-            <a:r>
-              <a:rPr lang="en-US" sz="1600" b="1" dirty="0">
-                <a:solidFill>
-                  <a:srgbClr val="17212B"/>
-                </a:solidFill>
-                <a:latin typeface="Microsoft YaHei" pitchFamily="34" charset="0"/>
-                <a:ea typeface="Microsoft YaHei" pitchFamily="34" charset="-122"/>
-                <a:cs typeface="Microsoft YaHei" pitchFamily="34" charset="-120"/>
-              </a:rPr>
-              <a:t>可替换</a:t>
-            </a:r>
-            <a:endParaRPr lang="en-US" sz="1600" dirty="0"/>
-          </a:p>
-        </p:txBody>
-      </p:sp>
-      <p:sp>
-        <p:nvSpPr>
-          <p:cNvPr id="37" name="Text 35"/>
-          <p:cNvSpPr/>
-          <p:nvPr/>
-        </p:nvSpPr>
-        <p:spPr>
-          <a:xfrm>
-            <a:off x="4672584" y="3721608"/>
-            <a:ext cx="2999232" cy="704088"/>
-          </a:xfrm>
-          <a:prstGeom prst="rect">
-            <a:avLst/>
-          </a:prstGeom>
-          <a:noFill/>
-          <a:ln/>
-        </p:spPr>
-        <p:txBody>
-          <a:bodyPr wrap="square" lIns="0" tIns="0" rIns="0" bIns="0" rtlCol="0" anchor="t">
-            <a:normAutofit/>
-          </a:bodyPr>
-          <a:lstStyle/>
-          <a:p>
-            <a:pPr indent="0" marL="0">
-              <a:buNone/>
-            </a:pPr>
-            <a:r>
-              <a:rPr lang="en-US" sz="1380" dirty="0">
-                <a:solidFill>
-                  <a:srgbClr val="24313D"/>
-                </a:solidFill>
-                <a:latin typeface="Microsoft YaHei" pitchFamily="34" charset="0"/>
-                <a:ea typeface="Microsoft YaHei" pitchFamily="34" charset="-122"/>
-                <a:cs typeface="Microsoft YaHei" pitchFamily="34" charset="-120"/>
-              </a:rPr>
-              <a:t>Embedding、向量库、生成模型都以模块封装，后续可替换为 BGE、FAISS、reranker。</a:t>
-            </a:r>
-            <a:endParaRPr lang="en-US" sz="1380" dirty="0"/>
-          </a:p>
-        </p:txBody>
-      </p:sp>
-      <p:sp>
-        <p:nvSpPr>
-          <p:cNvPr id="38" name="Shape 36"/>
-          <p:cNvSpPr/>
-          <p:nvPr/>
-        </p:nvSpPr>
-        <p:spPr>
-          <a:xfrm>
-            <a:off x="8092440" y="3154680"/>
-            <a:ext cx="3383280" cy="1417320"/>
-          </a:xfrm>
-          <a:prstGeom prst="roundRect">
-            <a:avLst>
-              <a:gd name="adj" fmla="val 2903"/>
-            </a:avLst>
-          </a:prstGeom>
-          <a:solidFill>
-            <a:srgbClr val="FFFFFF"/>
-          </a:solidFill>
-          <a:ln w="12700">
-            <a:solidFill>
-              <a:srgbClr val="CBD5E1"/>
-            </a:solidFill>
-            <a:prstDash val="solid"/>
-          </a:ln>
-          <a:effectLst>
-            <a:outerShdw sx="100000" sy="100000" kx="0" ky="0" algn="bl" rotWithShape="0" blurRad="12700" dist="50800" dir="2700000">
-              <a:srgbClr val="D7DEE8">
-                <a:alpha val="18000"/>
-              </a:srgbClr>
-            </a:outerShdw>
-          </a:effectLst>
-        </p:spPr>
-      </p:sp>
-      <p:sp>
-        <p:nvSpPr>
-          <p:cNvPr id="39" name="Shape 37"/>
-          <p:cNvSpPr/>
-          <p:nvPr/>
-        </p:nvSpPr>
-        <p:spPr>
-          <a:xfrm>
-            <a:off x="8092440" y="3154680"/>
-            <a:ext cx="91440" cy="1417320"/>
-          </a:xfrm>
-          <a:prstGeom prst="rect">
-            <a:avLst/>
-          </a:prstGeom>
-          <a:solidFill>
-            <a:srgbClr val="F59E0B"/>
-          </a:solidFill>
-          <a:ln w="12700">
-            <a:solidFill>
-              <a:srgbClr val="F59E0B"/>
-            </a:solidFill>
-            <a:prstDash val="solid"/>
-          </a:ln>
-        </p:spPr>
-      </p:sp>
-      <p:sp>
-        <p:nvSpPr>
-          <p:cNvPr id="40" name="Text 38"/>
-          <p:cNvSpPr/>
-          <p:nvPr/>
-        </p:nvSpPr>
-        <p:spPr>
-          <a:xfrm>
-            <a:off x="8330184" y="3319272"/>
-            <a:ext cx="2999232" cy="256032"/>
-          </a:xfrm>
-          <a:prstGeom prst="rect">
-            <a:avLst/>
-          </a:prstGeom>
-          <a:noFill/>
-          <a:ln/>
-        </p:spPr>
-        <p:txBody>
-          <a:bodyPr wrap="square" lIns="0" tIns="0" rIns="0" bIns="0" rtlCol="0" anchor="ctr">
-            <a:normAutofit/>
-          </a:bodyPr>
-          <a:lstStyle/>
-          <a:p>
-            <a:pPr indent="0" marL="0">
-              <a:buNone/>
-            </a:pPr>
-            <a:r>
-              <a:rPr lang="en-US" sz="1600" b="1" dirty="0">
-                <a:solidFill>
-                  <a:srgbClr val="17212B"/>
-                </a:solidFill>
-                <a:latin typeface="Microsoft YaHei" pitchFamily="34" charset="0"/>
-                <a:ea typeface="Microsoft YaHei" pitchFamily="34" charset="-122"/>
-                <a:cs typeface="Microsoft YaHei" pitchFamily="34" charset="-120"/>
-              </a:rPr>
-              <a:t>可复现</a:t>
-            </a:r>
-            <a:endParaRPr lang="en-US" sz="1600" dirty="0"/>
-          </a:p>
-        </p:txBody>
-      </p:sp>
-      <p:sp>
-        <p:nvSpPr>
-          <p:cNvPr id="41" name="Text 39"/>
-          <p:cNvSpPr/>
-          <p:nvPr/>
-        </p:nvSpPr>
-        <p:spPr>
-          <a:xfrm>
-            <a:off x="8330184" y="3721608"/>
-            <a:ext cx="2999232" cy="704088"/>
-          </a:xfrm>
-          <a:prstGeom prst="rect">
-            <a:avLst/>
-          </a:prstGeom>
-          <a:noFill/>
-          <a:ln/>
-        </p:spPr>
-        <p:txBody>
-          <a:bodyPr wrap="square" lIns="0" tIns="0" rIns="0" bIns="0" rtlCol="0" anchor="t">
-            <a:normAutofit/>
-          </a:bodyPr>
-          <a:lstStyle/>
-          <a:p>
-            <a:pPr indent="0" marL="0">
-              <a:buNone/>
-            </a:pPr>
-            <a:r>
-              <a:rPr lang="en-US" sz="1380" dirty="0">
-                <a:solidFill>
-                  <a:srgbClr val="24313D"/>
-                </a:solidFill>
-                <a:latin typeface="Microsoft YaHei" pitchFamily="34" charset="0"/>
-                <a:ea typeface="Microsoft YaHei" pitchFamily="34" charset="-122"/>
-                <a:cs typeface="Microsoft YaHei" pitchFamily="34" charset="-120"/>
-              </a:rPr>
-              <a:t>无 API key 自动回退抽取式生成，保证老师本地也能运行完整流程。</a:t>
-            </a:r>
-            <a:endParaRPr lang="en-US" sz="1380" dirty="0"/>
-          </a:p>
-        </p:txBody>
-      </p:sp>
-      <p:sp>
-        <p:nvSpPr>
-          <p:cNvPr id="42" name="Shape 40"/>
-          <p:cNvSpPr/>
-          <p:nvPr/>
-        </p:nvSpPr>
-        <p:spPr>
-          <a:xfrm>
-            <a:off x="566928" y="1042416"/>
-            <a:ext cx="11045952" cy="5102352"/>
-          </a:xfrm>
-          <a:prstGeom prst="roundRect">
-            <a:avLst>
-              <a:gd name="adj" fmla="val 717"/>
-            </a:avLst>
-          </a:prstGeom>
-          <a:solidFill>
-            <a:srgbClr val="FFFFFF"/>
-          </a:solidFill>
-          <a:ln w="12700">
-            <a:solidFill>
-              <a:srgbClr val="CBD5E1"/>
-            </a:solidFill>
-            <a:prstDash val="solid"/>
-          </a:ln>
         </p:spPr>
       </p:sp>
       <p:pic>
         <p:nvPicPr>
-          <p:cNvPr id="43" name="Image 0" descr="slides/assets/architecture_flow.png">    </p:cNvPr>
+          <p:cNvPr id="7" name="Image 0" descr="slides/assets/architecture_flow.png">    </p:cNvPr>
           <p:cNvPicPr>
             <a:picLocks noChangeAspect="1"/>
           </p:cNvPicPr>
@@ -4099,7 +2757,7 @@
         <p:spPr>
           <a:xfrm>
             <a:off x="621792" y="1097280"/>
-            <a:ext cx="10936224" cy="4992624"/>
+            <a:ext cx="10936224" cy="5010912"/>
           </a:xfrm>
           <a:prstGeom prst="rect">
             <a:avLst/>
@@ -5835,402 +4493,18 @@
       </p:sp>
       <p:sp>
         <p:nvSpPr>
-          <p:cNvPr id="6" name="Text 4"/>
-          <p:cNvSpPr/>
-          <p:nvPr/>
-        </p:nvSpPr>
-        <p:spPr>
-          <a:xfrm>
-            <a:off x="822960" y="1389888"/>
-            <a:ext cx="2377440" cy="228600"/>
-          </a:xfrm>
-          <a:prstGeom prst="rect">
-            <a:avLst/>
-          </a:prstGeom>
-          <a:noFill/>
-          <a:ln/>
-        </p:spPr>
-        <p:txBody>
-          <a:bodyPr wrap="square" lIns="0" tIns="0" rIns="0" bIns="0" rtlCol="0" anchor="ctr"/>
-          <a:lstStyle/>
-          <a:p>
-            <a:pPr indent="0" marL="0">
-              <a:buNone/>
-            </a:pPr>
-            <a:r>
-              <a:rPr lang="en-US" sz="1450" b="1" dirty="0">
-                <a:solidFill>
-                  <a:srgbClr val="17212B"/>
-                </a:solidFill>
-                <a:latin typeface="Microsoft YaHei" pitchFamily="34" charset="0"/>
-                <a:ea typeface="Microsoft YaHei" pitchFamily="34" charset="-122"/>
-                <a:cs typeface="Microsoft YaHei" pitchFamily="34" charset="-120"/>
-              </a:rPr>
-              <a:t>Context Relevance</a:t>
-            </a:r>
-            <a:endParaRPr lang="en-US" sz="1450" dirty="0"/>
-          </a:p>
-        </p:txBody>
-      </p:sp>
-      <p:sp>
-        <p:nvSpPr>
-          <p:cNvPr id="7" name="Shape 5"/>
-          <p:cNvSpPr/>
-          <p:nvPr/>
-        </p:nvSpPr>
-        <p:spPr>
-          <a:xfrm>
-            <a:off x="3383280" y="1417320"/>
-            <a:ext cx="5486400" cy="237744"/>
-          </a:xfrm>
-          <a:prstGeom prst="rect">
-            <a:avLst/>
-          </a:prstGeom>
-          <a:solidFill>
-            <a:srgbClr val="E5E7EB"/>
-          </a:solidFill>
-          <a:ln w="12700">
-            <a:solidFill>
-              <a:srgbClr val="E5E7EB"/>
-            </a:solidFill>
-            <a:prstDash val="solid"/>
-          </a:ln>
-        </p:spPr>
-      </p:sp>
-      <p:sp>
-        <p:nvSpPr>
-          <p:cNvPr id="8" name="Shape 6"/>
-          <p:cNvSpPr/>
-          <p:nvPr/>
-        </p:nvSpPr>
-        <p:spPr>
-          <a:xfrm>
-            <a:off x="3383280" y="1417320"/>
-            <a:ext cx="5486400" cy="237744"/>
-          </a:xfrm>
-          <a:prstGeom prst="rect">
-            <a:avLst/>
-          </a:prstGeom>
-          <a:solidFill>
-            <a:srgbClr val="D92D20"/>
-          </a:solidFill>
-          <a:ln w="12700">
-            <a:solidFill>
-              <a:srgbClr val="D92D20"/>
-            </a:solidFill>
-            <a:prstDash val="solid"/>
-          </a:ln>
-        </p:spPr>
-      </p:sp>
-      <p:sp>
-        <p:nvSpPr>
-          <p:cNvPr id="9" name="Text 7"/>
-          <p:cNvSpPr/>
-          <p:nvPr/>
-        </p:nvSpPr>
-        <p:spPr>
-          <a:xfrm>
-            <a:off x="9070848" y="1380744"/>
-            <a:ext cx="731520" cy="219456"/>
-          </a:xfrm>
-          <a:prstGeom prst="rect">
-            <a:avLst/>
-          </a:prstGeom>
-          <a:noFill/>
-          <a:ln/>
-        </p:spPr>
-        <p:txBody>
-          <a:bodyPr wrap="square" lIns="0" tIns="0" rIns="0" bIns="0" rtlCol="0" anchor="ctr"/>
-          <a:lstStyle/>
-          <a:p>
-            <a:pPr indent="0" marL="0">
-              <a:buNone/>
-            </a:pPr>
-            <a:r>
-              <a:rPr lang="en-US" sz="1350" b="1" dirty="0">
-                <a:solidFill>
-                  <a:srgbClr val="17212B"/>
-                </a:solidFill>
-                <a:latin typeface="Microsoft YaHei" pitchFamily="34" charset="0"/>
-                <a:ea typeface="Microsoft YaHei" pitchFamily="34" charset="-122"/>
-                <a:cs typeface="Microsoft YaHei" pitchFamily="34" charset="-120"/>
-              </a:rPr>
-              <a:t>1.0000</a:t>
-            </a:r>
-            <a:endParaRPr lang="en-US" sz="1350" dirty="0"/>
-          </a:p>
-        </p:txBody>
-      </p:sp>
-      <p:sp>
-        <p:nvSpPr>
-          <p:cNvPr id="10" name="Text 8"/>
-          <p:cNvSpPr/>
-          <p:nvPr/>
-        </p:nvSpPr>
-        <p:spPr>
-          <a:xfrm>
-            <a:off x="822960" y="2487168"/>
-            <a:ext cx="2377440" cy="228600"/>
-          </a:xfrm>
-          <a:prstGeom prst="rect">
-            <a:avLst/>
-          </a:prstGeom>
-          <a:noFill/>
-          <a:ln/>
-        </p:spPr>
-        <p:txBody>
-          <a:bodyPr wrap="square" lIns="0" tIns="0" rIns="0" bIns="0" rtlCol="0" anchor="ctr"/>
-          <a:lstStyle/>
-          <a:p>
-            <a:pPr indent="0" marL="0">
-              <a:buNone/>
-            </a:pPr>
-            <a:r>
-              <a:rPr lang="en-US" sz="1450" b="1" dirty="0">
-                <a:solidFill>
-                  <a:srgbClr val="17212B"/>
-                </a:solidFill>
-                <a:latin typeface="Microsoft YaHei" pitchFamily="34" charset="0"/>
-                <a:ea typeface="Microsoft YaHei" pitchFamily="34" charset="-122"/>
-                <a:cs typeface="Microsoft YaHei" pitchFamily="34" charset="-120"/>
-              </a:rPr>
-              <a:t>Faithfulness</a:t>
-            </a:r>
-            <a:endParaRPr lang="en-US" sz="1450" dirty="0"/>
-          </a:p>
-        </p:txBody>
-      </p:sp>
-      <p:sp>
-        <p:nvSpPr>
-          <p:cNvPr id="11" name="Shape 9"/>
-          <p:cNvSpPr/>
-          <p:nvPr/>
-        </p:nvSpPr>
-        <p:spPr>
-          <a:xfrm>
-            <a:off x="3383280" y="2514600"/>
-            <a:ext cx="5486400" cy="237744"/>
-          </a:xfrm>
-          <a:prstGeom prst="rect">
-            <a:avLst/>
-          </a:prstGeom>
-          <a:solidFill>
-            <a:srgbClr val="E5E7EB"/>
-          </a:solidFill>
-          <a:ln w="12700">
-            <a:solidFill>
-              <a:srgbClr val="E5E7EB"/>
-            </a:solidFill>
-            <a:prstDash val="solid"/>
-          </a:ln>
-        </p:spPr>
-      </p:sp>
-      <p:sp>
-        <p:nvSpPr>
-          <p:cNvPr id="12" name="Shape 10"/>
-          <p:cNvSpPr/>
-          <p:nvPr/>
-        </p:nvSpPr>
-        <p:spPr>
-          <a:xfrm>
-            <a:off x="3383280" y="2514600"/>
-            <a:ext cx="4452762" cy="237744"/>
-          </a:xfrm>
-          <a:prstGeom prst="rect">
-            <a:avLst/>
-          </a:prstGeom>
-          <a:solidFill>
-            <a:srgbClr val="0F766E"/>
-          </a:solidFill>
-          <a:ln w="12700">
-            <a:solidFill>
-              <a:srgbClr val="0F766E"/>
-            </a:solidFill>
-            <a:prstDash val="solid"/>
-          </a:ln>
-        </p:spPr>
-      </p:sp>
-      <p:sp>
-        <p:nvSpPr>
-          <p:cNvPr id="13" name="Text 11"/>
-          <p:cNvSpPr/>
-          <p:nvPr/>
-        </p:nvSpPr>
-        <p:spPr>
-          <a:xfrm>
-            <a:off x="9070848" y="2478024"/>
-            <a:ext cx="731520" cy="219456"/>
-          </a:xfrm>
-          <a:prstGeom prst="rect">
-            <a:avLst/>
-          </a:prstGeom>
-          <a:noFill/>
-          <a:ln/>
-        </p:spPr>
-        <p:txBody>
-          <a:bodyPr wrap="square" lIns="0" tIns="0" rIns="0" bIns="0" rtlCol="0" anchor="ctr"/>
-          <a:lstStyle/>
-          <a:p>
-            <a:pPr indent="0" marL="0">
-              <a:buNone/>
-            </a:pPr>
-            <a:r>
-              <a:rPr lang="en-US" sz="1350" b="1" dirty="0">
-                <a:solidFill>
-                  <a:srgbClr val="17212B"/>
-                </a:solidFill>
-                <a:latin typeface="Microsoft YaHei" pitchFamily="34" charset="0"/>
-                <a:ea typeface="Microsoft YaHei" pitchFamily="34" charset="-122"/>
-                <a:cs typeface="Microsoft YaHei" pitchFamily="34" charset="-120"/>
-              </a:rPr>
-              <a:t>0.8116</a:t>
-            </a:r>
-            <a:endParaRPr lang="en-US" sz="1350" dirty="0"/>
-          </a:p>
-        </p:txBody>
-      </p:sp>
-      <p:sp>
-        <p:nvSpPr>
-          <p:cNvPr id="14" name="Text 12"/>
-          <p:cNvSpPr/>
-          <p:nvPr/>
-        </p:nvSpPr>
-        <p:spPr>
-          <a:xfrm>
-            <a:off x="822960" y="3584448"/>
-            <a:ext cx="2377440" cy="228600"/>
-          </a:xfrm>
-          <a:prstGeom prst="rect">
-            <a:avLst/>
-          </a:prstGeom>
-          <a:noFill/>
-          <a:ln/>
-        </p:spPr>
-        <p:txBody>
-          <a:bodyPr wrap="square" lIns="0" tIns="0" rIns="0" bIns="0" rtlCol="0" anchor="ctr"/>
-          <a:lstStyle/>
-          <a:p>
-            <a:pPr indent="0" marL="0">
-              <a:buNone/>
-            </a:pPr>
-            <a:r>
-              <a:rPr lang="en-US" sz="1450" b="1" dirty="0">
-                <a:solidFill>
-                  <a:srgbClr val="17212B"/>
-                </a:solidFill>
-                <a:latin typeface="Microsoft YaHei" pitchFamily="34" charset="0"/>
-                <a:ea typeface="Microsoft YaHei" pitchFamily="34" charset="-122"/>
-                <a:cs typeface="Microsoft YaHei" pitchFamily="34" charset="-120"/>
-              </a:rPr>
-              <a:t>Answer Relevance</a:t>
-            </a:r>
-            <a:endParaRPr lang="en-US" sz="1450" dirty="0"/>
-          </a:p>
-        </p:txBody>
-      </p:sp>
-      <p:sp>
-        <p:nvSpPr>
-          <p:cNvPr id="15" name="Shape 13"/>
-          <p:cNvSpPr/>
-          <p:nvPr/>
-        </p:nvSpPr>
-        <p:spPr>
-          <a:xfrm>
-            <a:off x="3383280" y="3611880"/>
-            <a:ext cx="5486400" cy="237744"/>
-          </a:xfrm>
-          <a:prstGeom prst="rect">
-            <a:avLst/>
-          </a:prstGeom>
-          <a:solidFill>
-            <a:srgbClr val="E5E7EB"/>
-          </a:solidFill>
-          <a:ln w="12700">
-            <a:solidFill>
-              <a:srgbClr val="E5E7EB"/>
-            </a:solidFill>
-            <a:prstDash val="solid"/>
-          </a:ln>
-        </p:spPr>
-      </p:sp>
-      <p:sp>
-        <p:nvSpPr>
-          <p:cNvPr id="16" name="Shape 14"/>
-          <p:cNvSpPr/>
-          <p:nvPr/>
-        </p:nvSpPr>
-        <p:spPr>
-          <a:xfrm>
-            <a:off x="3383280" y="3611880"/>
-            <a:ext cx="4800600" cy="237744"/>
-          </a:xfrm>
-          <a:prstGeom prst="rect">
-            <a:avLst/>
-          </a:prstGeom>
-          <a:solidFill>
-            <a:srgbClr val="F59E0B"/>
-          </a:solidFill>
-          <a:ln w="12700">
-            <a:solidFill>
-              <a:srgbClr val="F59E0B"/>
-            </a:solidFill>
-            <a:prstDash val="solid"/>
-          </a:ln>
-        </p:spPr>
-      </p:sp>
-      <p:sp>
-        <p:nvSpPr>
-          <p:cNvPr id="17" name="Text 15"/>
-          <p:cNvSpPr/>
-          <p:nvPr/>
-        </p:nvSpPr>
-        <p:spPr>
-          <a:xfrm>
-            <a:off x="9070848" y="3575304"/>
-            <a:ext cx="731520" cy="219456"/>
-          </a:xfrm>
-          <a:prstGeom prst="rect">
-            <a:avLst/>
-          </a:prstGeom>
-          <a:noFill/>
-          <a:ln/>
-        </p:spPr>
-        <p:txBody>
-          <a:bodyPr wrap="square" lIns="0" tIns="0" rIns="0" bIns="0" rtlCol="0" anchor="ctr"/>
-          <a:lstStyle/>
-          <a:p>
-            <a:pPr indent="0" marL="0">
-              <a:buNone/>
-            </a:pPr>
-            <a:r>
-              <a:rPr lang="en-US" sz="1350" b="1" dirty="0">
-                <a:solidFill>
-                  <a:srgbClr val="17212B"/>
-                </a:solidFill>
-                <a:latin typeface="Microsoft YaHei" pitchFamily="34" charset="0"/>
-                <a:ea typeface="Microsoft YaHei" pitchFamily="34" charset="-122"/>
-                <a:cs typeface="Microsoft YaHei" pitchFamily="34" charset="-120"/>
-              </a:rPr>
-              <a:t>0.8750</a:t>
-            </a:r>
-            <a:endParaRPr lang="en-US" sz="1350" dirty="0"/>
-          </a:p>
-        </p:txBody>
-      </p:sp>
-      <p:sp>
-        <p:nvSpPr>
-          <p:cNvPr id="18" name="Shape 16"/>
-          <p:cNvSpPr/>
-          <p:nvPr/>
-        </p:nvSpPr>
-        <p:spPr>
-          <a:xfrm>
-            <a:off x="8183880" y="1143000"/>
-            <a:ext cx="3154680" cy="1234440"/>
+          <p:cNvPr id="6" name="Shape 4"/>
+          <p:cNvSpPr/>
+          <p:nvPr/>
+        </p:nvSpPr>
+        <p:spPr>
+          <a:xfrm>
+            <a:off x="566928" y="1024128"/>
+            <a:ext cx="11045952" cy="5230368"/>
           </a:xfrm>
           <a:prstGeom prst="roundRect">
             <a:avLst>
-              <a:gd name="adj" fmla="val 3333"/>
+              <a:gd name="adj" fmla="val 699"/>
             </a:avLst>
           </a:prstGeom>
           <a:solidFill>
@@ -6242,434 +4516,11 @@
             </a:solidFill>
             <a:prstDash val="solid"/>
           </a:ln>
-          <a:effectLst>
-            <a:outerShdw sx="100000" sy="100000" kx="0" ky="0" algn="bl" rotWithShape="0" blurRad="12700" dist="50800" dir="2700000">
-              <a:srgbClr val="D7DEE8">
-                <a:alpha val="18000"/>
-              </a:srgbClr>
-            </a:outerShdw>
-          </a:effectLst>
-        </p:spPr>
-      </p:sp>
-      <p:sp>
-        <p:nvSpPr>
-          <p:cNvPr id="19" name="Shape 17"/>
-          <p:cNvSpPr/>
-          <p:nvPr/>
-        </p:nvSpPr>
-        <p:spPr>
-          <a:xfrm>
-            <a:off x="8183880" y="1143000"/>
-            <a:ext cx="91440" cy="1234440"/>
-          </a:xfrm>
-          <a:prstGeom prst="rect">
-            <a:avLst/>
-          </a:prstGeom>
-          <a:solidFill>
-            <a:srgbClr val="D92D20"/>
-          </a:solidFill>
-          <a:ln w="12700">
-            <a:solidFill>
-              <a:srgbClr val="D92D20"/>
-            </a:solidFill>
-            <a:prstDash val="solid"/>
-          </a:ln>
-        </p:spPr>
-      </p:sp>
-      <p:sp>
-        <p:nvSpPr>
-          <p:cNvPr id="20" name="Text 18"/>
-          <p:cNvSpPr/>
-          <p:nvPr/>
-        </p:nvSpPr>
-        <p:spPr>
-          <a:xfrm>
-            <a:off x="8421624" y="1307592"/>
-            <a:ext cx="2770632" cy="256032"/>
-          </a:xfrm>
-          <a:prstGeom prst="rect">
-            <a:avLst/>
-          </a:prstGeom>
-          <a:noFill/>
-          <a:ln/>
-        </p:spPr>
-        <p:txBody>
-          <a:bodyPr wrap="square" lIns="0" tIns="0" rIns="0" bIns="0" rtlCol="0" anchor="ctr">
-            <a:normAutofit/>
-          </a:bodyPr>
-          <a:lstStyle/>
-          <a:p>
-            <a:pPr indent="0" marL="0">
-              <a:buNone/>
-            </a:pPr>
-            <a:r>
-              <a:rPr lang="en-US" sz="1600" b="1" dirty="0">
-                <a:solidFill>
-                  <a:srgbClr val="17212B"/>
-                </a:solidFill>
-                <a:latin typeface="Microsoft YaHei" pitchFamily="34" charset="0"/>
-                <a:ea typeface="Microsoft YaHei" pitchFamily="34" charset="-122"/>
-                <a:cs typeface="Microsoft YaHei" pitchFamily="34" charset="-120"/>
-              </a:rPr>
-              <a:t>检索表现</a:t>
-            </a:r>
-            <a:endParaRPr lang="en-US" sz="1600" dirty="0"/>
-          </a:p>
-        </p:txBody>
-      </p:sp>
-      <p:sp>
-        <p:nvSpPr>
-          <p:cNvPr id="21" name="Text 19"/>
-          <p:cNvSpPr/>
-          <p:nvPr/>
-        </p:nvSpPr>
-        <p:spPr>
-          <a:xfrm>
-            <a:off x="8421624" y="1709928"/>
-            <a:ext cx="2770632" cy="521208"/>
-          </a:xfrm>
-          <a:prstGeom prst="rect">
-            <a:avLst/>
-          </a:prstGeom>
-          <a:noFill/>
-          <a:ln/>
-        </p:spPr>
-        <p:txBody>
-          <a:bodyPr wrap="square" lIns="0" tIns="0" rIns="0" bIns="0" rtlCol="0" anchor="t">
-            <a:normAutofit/>
-          </a:bodyPr>
-          <a:lstStyle/>
-          <a:p>
-            <a:pPr indent="0" marL="0">
-              <a:buNone/>
-            </a:pPr>
-            <a:r>
-              <a:rPr lang="en-US" sz="1350" dirty="0">
-                <a:solidFill>
-                  <a:srgbClr val="24313D"/>
-                </a:solidFill>
-                <a:latin typeface="Microsoft YaHei" pitchFamily="34" charset="0"/>
-                <a:ea typeface="Microsoft YaHei" pitchFamily="34" charset="-122"/>
-                <a:cs typeface="Microsoft YaHei" pitchFamily="34" charset="-120"/>
-              </a:rPr>
-              <a:t>相关文档覆盖率达到 1.0000，说明混合检索能稳定召回正确文档。</a:t>
-            </a:r>
-            <a:endParaRPr lang="en-US" sz="1350" dirty="0"/>
-          </a:p>
-        </p:txBody>
-      </p:sp>
-      <p:sp>
-        <p:nvSpPr>
-          <p:cNvPr id="22" name="Shape 20"/>
-          <p:cNvSpPr/>
-          <p:nvPr/>
-        </p:nvSpPr>
-        <p:spPr>
-          <a:xfrm>
-            <a:off x="8183880" y="2697480"/>
-            <a:ext cx="3154680" cy="1234440"/>
-          </a:xfrm>
-          <a:prstGeom prst="roundRect">
-            <a:avLst>
-              <a:gd name="adj" fmla="val 3333"/>
-            </a:avLst>
-          </a:prstGeom>
-          <a:solidFill>
-            <a:srgbClr val="FFFFFF"/>
-          </a:solidFill>
-          <a:ln w="12700">
-            <a:solidFill>
-              <a:srgbClr val="CBD5E1"/>
-            </a:solidFill>
-            <a:prstDash val="solid"/>
-          </a:ln>
-          <a:effectLst>
-            <a:outerShdw sx="100000" sy="100000" kx="0" ky="0" algn="bl" rotWithShape="0" blurRad="12700" dist="50800" dir="2700000">
-              <a:srgbClr val="D7DEE8">
-                <a:alpha val="18000"/>
-              </a:srgbClr>
-            </a:outerShdw>
-          </a:effectLst>
-        </p:spPr>
-      </p:sp>
-      <p:sp>
-        <p:nvSpPr>
-          <p:cNvPr id="23" name="Shape 21"/>
-          <p:cNvSpPr/>
-          <p:nvPr/>
-        </p:nvSpPr>
-        <p:spPr>
-          <a:xfrm>
-            <a:off x="8183880" y="2697480"/>
-            <a:ext cx="91440" cy="1234440"/>
-          </a:xfrm>
-          <a:prstGeom prst="rect">
-            <a:avLst/>
-          </a:prstGeom>
-          <a:solidFill>
-            <a:srgbClr val="0F766E"/>
-          </a:solidFill>
-          <a:ln w="12700">
-            <a:solidFill>
-              <a:srgbClr val="0F766E"/>
-            </a:solidFill>
-            <a:prstDash val="solid"/>
-          </a:ln>
-        </p:spPr>
-      </p:sp>
-      <p:sp>
-        <p:nvSpPr>
-          <p:cNvPr id="24" name="Text 22"/>
-          <p:cNvSpPr/>
-          <p:nvPr/>
-        </p:nvSpPr>
-        <p:spPr>
-          <a:xfrm>
-            <a:off x="8421624" y="2862072"/>
-            <a:ext cx="2770632" cy="256032"/>
-          </a:xfrm>
-          <a:prstGeom prst="rect">
-            <a:avLst/>
-          </a:prstGeom>
-          <a:noFill/>
-          <a:ln/>
-        </p:spPr>
-        <p:txBody>
-          <a:bodyPr wrap="square" lIns="0" tIns="0" rIns="0" bIns="0" rtlCol="0" anchor="ctr">
-            <a:normAutofit/>
-          </a:bodyPr>
-          <a:lstStyle/>
-          <a:p>
-            <a:pPr indent="0" marL="0">
-              <a:buNone/>
-            </a:pPr>
-            <a:r>
-              <a:rPr lang="en-US" sz="1600" b="1" dirty="0">
-                <a:solidFill>
-                  <a:srgbClr val="17212B"/>
-                </a:solidFill>
-                <a:latin typeface="Microsoft YaHei" pitchFamily="34" charset="0"/>
-                <a:ea typeface="Microsoft YaHei" pitchFamily="34" charset="-122"/>
-                <a:cs typeface="Microsoft YaHei" pitchFamily="34" charset="-120"/>
-              </a:rPr>
-              <a:t>生成表现</a:t>
-            </a:r>
-            <a:endParaRPr lang="en-US" sz="1600" dirty="0"/>
-          </a:p>
-        </p:txBody>
-      </p:sp>
-      <p:sp>
-        <p:nvSpPr>
-          <p:cNvPr id="25" name="Text 23"/>
-          <p:cNvSpPr/>
-          <p:nvPr/>
-        </p:nvSpPr>
-        <p:spPr>
-          <a:xfrm>
-            <a:off x="8421624" y="3264408"/>
-            <a:ext cx="2770632" cy="521208"/>
-          </a:xfrm>
-          <a:prstGeom prst="rect">
-            <a:avLst/>
-          </a:prstGeom>
-          <a:noFill/>
-          <a:ln/>
-        </p:spPr>
-        <p:txBody>
-          <a:bodyPr wrap="square" lIns="0" tIns="0" rIns="0" bIns="0" rtlCol="0" anchor="t">
-            <a:normAutofit/>
-          </a:bodyPr>
-          <a:lstStyle/>
-          <a:p>
-            <a:pPr indent="0" marL="0">
-              <a:buNone/>
-            </a:pPr>
-            <a:r>
-              <a:rPr lang="en-US" sz="1350" dirty="0">
-                <a:solidFill>
-                  <a:srgbClr val="24313D"/>
-                </a:solidFill>
-                <a:latin typeface="Microsoft YaHei" pitchFamily="34" charset="0"/>
-                <a:ea typeface="Microsoft YaHei" pitchFamily="34" charset="-122"/>
-                <a:cs typeface="Microsoft YaHei" pitchFamily="34" charset="-120"/>
-              </a:rPr>
-              <a:t>Faithfulness 为 0.8116，答案多数内容可由上下文支持。</a:t>
-            </a:r>
-            <a:endParaRPr lang="en-US" sz="1350" dirty="0"/>
-          </a:p>
-        </p:txBody>
-      </p:sp>
-      <p:sp>
-        <p:nvSpPr>
-          <p:cNvPr id="26" name="Shape 24"/>
-          <p:cNvSpPr/>
-          <p:nvPr/>
-        </p:nvSpPr>
-        <p:spPr>
-          <a:xfrm>
-            <a:off x="8183880" y="4251960"/>
-            <a:ext cx="3154680" cy="1234440"/>
-          </a:xfrm>
-          <a:prstGeom prst="roundRect">
-            <a:avLst>
-              <a:gd name="adj" fmla="val 3333"/>
-            </a:avLst>
-          </a:prstGeom>
-          <a:solidFill>
-            <a:srgbClr val="FFFFFF"/>
-          </a:solidFill>
-          <a:ln w="12700">
-            <a:solidFill>
-              <a:srgbClr val="CBD5E1"/>
-            </a:solidFill>
-            <a:prstDash val="solid"/>
-          </a:ln>
-          <a:effectLst>
-            <a:outerShdw sx="100000" sy="100000" kx="0" ky="0" algn="bl" rotWithShape="0" blurRad="12700" dist="50800" dir="2700000">
-              <a:srgbClr val="D7DEE8">
-                <a:alpha val="18000"/>
-              </a:srgbClr>
-            </a:outerShdw>
-          </a:effectLst>
-        </p:spPr>
-      </p:sp>
-      <p:sp>
-        <p:nvSpPr>
-          <p:cNvPr id="27" name="Shape 25"/>
-          <p:cNvSpPr/>
-          <p:nvPr/>
-        </p:nvSpPr>
-        <p:spPr>
-          <a:xfrm>
-            <a:off x="8183880" y="4251960"/>
-            <a:ext cx="91440" cy="1234440"/>
-          </a:xfrm>
-          <a:prstGeom prst="rect">
-            <a:avLst/>
-          </a:prstGeom>
-          <a:solidFill>
-            <a:srgbClr val="F59E0B"/>
-          </a:solidFill>
-          <a:ln w="12700">
-            <a:solidFill>
-              <a:srgbClr val="F59E0B"/>
-            </a:solidFill>
-            <a:prstDash val="solid"/>
-          </a:ln>
-        </p:spPr>
-      </p:sp>
-      <p:sp>
-        <p:nvSpPr>
-          <p:cNvPr id="28" name="Text 26"/>
-          <p:cNvSpPr/>
-          <p:nvPr/>
-        </p:nvSpPr>
-        <p:spPr>
-          <a:xfrm>
-            <a:off x="8421624" y="4416552"/>
-            <a:ext cx="2770632" cy="256032"/>
-          </a:xfrm>
-          <a:prstGeom prst="rect">
-            <a:avLst/>
-          </a:prstGeom>
-          <a:noFill/>
-          <a:ln/>
-        </p:spPr>
-        <p:txBody>
-          <a:bodyPr wrap="square" lIns="0" tIns="0" rIns="0" bIns="0" rtlCol="0" anchor="ctr">
-            <a:normAutofit/>
-          </a:bodyPr>
-          <a:lstStyle/>
-          <a:p>
-            <a:pPr indent="0" marL="0">
-              <a:buNone/>
-            </a:pPr>
-            <a:r>
-              <a:rPr lang="en-US" sz="1600" b="1" dirty="0">
-                <a:solidFill>
-                  <a:srgbClr val="17212B"/>
-                </a:solidFill>
-                <a:latin typeface="Microsoft YaHei" pitchFamily="34" charset="0"/>
-                <a:ea typeface="Microsoft YaHei" pitchFamily="34" charset="-122"/>
-                <a:cs typeface="Microsoft YaHei" pitchFamily="34" charset="-120"/>
-              </a:rPr>
-              <a:t>剩余问题</a:t>
-            </a:r>
-            <a:endParaRPr lang="en-US" sz="1600" dirty="0"/>
-          </a:p>
-        </p:txBody>
-      </p:sp>
-      <p:sp>
-        <p:nvSpPr>
-          <p:cNvPr id="29" name="Text 27"/>
-          <p:cNvSpPr/>
-          <p:nvPr/>
-        </p:nvSpPr>
-        <p:spPr>
-          <a:xfrm>
-            <a:off x="8421624" y="4818888"/>
-            <a:ext cx="2770632" cy="521208"/>
-          </a:xfrm>
-          <a:prstGeom prst="rect">
-            <a:avLst/>
-          </a:prstGeom>
-          <a:noFill/>
-          <a:ln/>
-        </p:spPr>
-        <p:txBody>
-          <a:bodyPr wrap="square" lIns="0" tIns="0" rIns="0" bIns="0" rtlCol="0" anchor="t">
-            <a:normAutofit/>
-          </a:bodyPr>
-          <a:lstStyle/>
-          <a:p>
-            <a:pPr indent="0" marL="0">
-              <a:buNone/>
-            </a:pPr>
-            <a:r>
-              <a:rPr lang="en-US" sz="1350" dirty="0">
-                <a:solidFill>
-                  <a:srgbClr val="24313D"/>
-                </a:solidFill>
-                <a:latin typeface="Microsoft YaHei" pitchFamily="34" charset="0"/>
-                <a:ea typeface="Microsoft YaHei" pitchFamily="34" charset="-122"/>
-                <a:cs typeface="Microsoft YaHei" pitchFamily="34" charset="-120"/>
-              </a:rPr>
-              <a:t>部分关键词未完全覆盖，主要来自抽取式答案表达不够自然。</a:t>
-            </a:r>
-            <a:endParaRPr lang="en-US" sz="1350" dirty="0"/>
-          </a:p>
-        </p:txBody>
-      </p:sp>
-      <p:sp>
-        <p:nvSpPr>
-          <p:cNvPr id="30" name="Shape 28"/>
-          <p:cNvSpPr/>
-          <p:nvPr/>
-        </p:nvSpPr>
-        <p:spPr>
-          <a:xfrm>
-            <a:off x="502920" y="1024128"/>
-            <a:ext cx="7132320" cy="4983480"/>
-          </a:xfrm>
-          <a:prstGeom prst="roundRect">
-            <a:avLst>
-              <a:gd name="adj" fmla="val 734"/>
-            </a:avLst>
-          </a:prstGeom>
-          <a:solidFill>
-            <a:srgbClr val="FFFFFF"/>
-          </a:solidFill>
-          <a:ln w="12700">
-            <a:solidFill>
-              <a:srgbClr val="CBD5E1"/>
-            </a:solidFill>
-            <a:prstDash val="solid"/>
-          </a:ln>
         </p:spPr>
       </p:sp>
       <p:pic>
         <p:nvPicPr>
-          <p:cNvPr id="31" name="Image 0" descr="slides/assets/evaluation_results.png">    </p:cNvPr>
+          <p:cNvPr id="7" name="Image 0" descr="slides/assets/evaluation_results.png">    </p:cNvPr>
           <p:cNvPicPr>
             <a:picLocks noChangeAspect="1"/>
           </p:cNvPicPr>
@@ -6683,8 +4534,8 @@
         </p:blipFill>
         <p:spPr>
           <a:xfrm>
-            <a:off x="557784" y="1078992"/>
-            <a:ext cx="7022592" cy="4873752"/>
+            <a:off x="621792" y="1078992"/>
+            <a:ext cx="10936224" cy="5120640"/>
           </a:xfrm>
           <a:prstGeom prst="rect">
             <a:avLst/>
@@ -6875,80 +4726,12 @@
         </p:nvSpPr>
         <p:spPr>
           <a:xfrm>
-            <a:off x="777240" y="1143000"/>
-            <a:ext cx="10652760" cy="594360"/>
+            <a:off x="566928" y="1024128"/>
+            <a:ext cx="11045952" cy="5230368"/>
           </a:xfrm>
           <a:prstGeom prst="roundRect">
             <a:avLst>
-              <a:gd name="adj" fmla="val 6154"/>
-            </a:avLst>
-          </a:prstGeom>
-          <a:solidFill>
-            <a:srgbClr val="FDE8E5"/>
-          </a:solidFill>
-          <a:ln w="12700">
-            <a:solidFill>
-              <a:srgbClr val="F8C5BD"/>
-            </a:solidFill>
-            <a:prstDash val="solid"/>
-          </a:ln>
-        </p:spPr>
-      </p:sp>
-      <p:sp>
-        <p:nvSpPr>
-          <p:cNvPr id="7" name="Text 5"/>
-          <p:cNvSpPr/>
-          <p:nvPr/>
-        </p:nvSpPr>
-        <p:spPr>
-          <a:xfrm>
-            <a:off x="1051560" y="1325880"/>
-            <a:ext cx="9966960" cy="201168"/>
-          </a:xfrm>
-          <a:prstGeom prst="rect">
-            <a:avLst/>
-          </a:prstGeom>
-          <a:noFill/>
-          <a:ln/>
-        </p:spPr>
-        <p:txBody>
-          <a:bodyPr wrap="square" lIns="0" tIns="0" rIns="0" bIns="0" rtlCol="0" anchor="ctr">
-            <a:normAutofit/>
-          </a:bodyPr>
-          <a:lstStyle/>
-          <a:p>
-            <a:pPr indent="0" marL="0">
-              <a:buNone/>
-            </a:pPr>
-            <a:r>
-              <a:rPr lang="en-US" sz="1600" b="1" dirty="0">
-                <a:solidFill>
-                  <a:srgbClr val="8A1C14"/>
-                </a:solidFill>
-                <a:latin typeface="Microsoft YaHei" pitchFamily="34" charset="0"/>
-                <a:ea typeface="Microsoft YaHei" pitchFamily="34" charset="-122"/>
-                <a:cs typeface="Microsoft YaHei" pitchFamily="34" charset="-120"/>
-              </a:rPr>
-              <a:t>问题：Redis 的 AOF 和 RDB 持久化有什么区别？</a:t>
-            </a:r>
-            <a:endParaRPr lang="en-US" sz="1600" dirty="0"/>
-          </a:p>
-        </p:txBody>
-      </p:sp>
-      <p:sp>
-        <p:nvSpPr>
-          <p:cNvPr id="8" name="Shape 6"/>
-          <p:cNvSpPr/>
-          <p:nvPr/>
-        </p:nvSpPr>
-        <p:spPr>
-          <a:xfrm>
-            <a:off x="822960" y="2148840"/>
-            <a:ext cx="3337560" cy="2011680"/>
-          </a:xfrm>
-          <a:prstGeom prst="roundRect">
-            <a:avLst>
-              <a:gd name="adj" fmla="val 2045"/>
+              <a:gd name="adj" fmla="val 699"/>
             </a:avLst>
           </a:prstGeom>
           <a:solidFill>
@@ -6960,509 +4743,11 @@
             </a:solidFill>
             <a:prstDash val="solid"/>
           </a:ln>
-          <a:effectLst>
-            <a:outerShdw sx="100000" sy="100000" kx="0" ky="0" algn="bl" rotWithShape="0" blurRad="12700" dist="50800" dir="2700000">
-              <a:srgbClr val="D7DEE8">
-                <a:alpha val="18000"/>
-              </a:srgbClr>
-            </a:outerShdw>
-          </a:effectLst>
-        </p:spPr>
-      </p:sp>
-      <p:sp>
-        <p:nvSpPr>
-          <p:cNvPr id="9" name="Shape 7"/>
-          <p:cNvSpPr/>
-          <p:nvPr/>
-        </p:nvSpPr>
-        <p:spPr>
-          <a:xfrm>
-            <a:off x="822960" y="2148840"/>
-            <a:ext cx="91440" cy="2011680"/>
-          </a:xfrm>
-          <a:prstGeom prst="rect">
-            <a:avLst/>
-          </a:prstGeom>
-          <a:solidFill>
-            <a:srgbClr val="D92D20"/>
-          </a:solidFill>
-          <a:ln w="12700">
-            <a:solidFill>
-              <a:srgbClr val="D92D20"/>
-            </a:solidFill>
-            <a:prstDash val="solid"/>
-          </a:ln>
-        </p:spPr>
-      </p:sp>
-      <p:sp>
-        <p:nvSpPr>
-          <p:cNvPr id="10" name="Text 8"/>
-          <p:cNvSpPr/>
-          <p:nvPr/>
-        </p:nvSpPr>
-        <p:spPr>
-          <a:xfrm>
-            <a:off x="1060704" y="2313432"/>
-            <a:ext cx="2953512" cy="256032"/>
-          </a:xfrm>
-          <a:prstGeom prst="rect">
-            <a:avLst/>
-          </a:prstGeom>
-          <a:noFill/>
-          <a:ln/>
-        </p:spPr>
-        <p:txBody>
-          <a:bodyPr wrap="square" lIns="0" tIns="0" rIns="0" bIns="0" rtlCol="0" anchor="ctr">
-            <a:normAutofit/>
-          </a:bodyPr>
-          <a:lstStyle/>
-          <a:p>
-            <a:pPr indent="0" marL="0">
-              <a:buNone/>
-            </a:pPr>
-            <a:r>
-              <a:rPr lang="en-US" sz="1600" b="1" dirty="0">
-                <a:solidFill>
-                  <a:srgbClr val="17212B"/>
-                </a:solidFill>
-                <a:latin typeface="Microsoft YaHei" pitchFamily="34" charset="0"/>
-                <a:ea typeface="Microsoft YaHei" pitchFamily="34" charset="-122"/>
-                <a:cs typeface="Microsoft YaHei" pitchFamily="34" charset="-120"/>
-              </a:rPr>
-              <a:t>命中文档</a:t>
-            </a:r>
-            <a:endParaRPr lang="en-US" sz="1600" dirty="0"/>
-          </a:p>
-        </p:txBody>
-      </p:sp>
-      <p:sp>
-        <p:nvSpPr>
-          <p:cNvPr id="11" name="Text 9"/>
-          <p:cNvSpPr/>
-          <p:nvPr/>
-        </p:nvSpPr>
-        <p:spPr>
-          <a:xfrm>
-            <a:off x="1060704" y="2715768"/>
-            <a:ext cx="2953512" cy="1298448"/>
-          </a:xfrm>
-          <a:prstGeom prst="rect">
-            <a:avLst/>
-          </a:prstGeom>
-          <a:noFill/>
-          <a:ln/>
-        </p:spPr>
-        <p:txBody>
-          <a:bodyPr wrap="square" lIns="0" tIns="0" rIns="0" bIns="0" rtlCol="0" anchor="t">
-            <a:normAutofit/>
-          </a:bodyPr>
-          <a:lstStyle/>
-          <a:p>
-            <a:pPr indent="0" marL="0">
-              <a:buNone/>
-            </a:pPr>
-            <a:r>
-              <a:rPr lang="en-US" sz="1400" dirty="0">
-                <a:solidFill>
-                  <a:srgbClr val="24313D"/>
-                </a:solidFill>
-                <a:latin typeface="Microsoft YaHei" pitchFamily="34" charset="0"/>
-                <a:ea typeface="Microsoft YaHei" pitchFamily="34" charset="-122"/>
-                <a:cs typeface="Microsoft YaHei" pitchFamily="34" charset="-120"/>
-              </a:rPr>
-              <a:t>redis:persistence</a:t>
-            </a:r>
-            <a:endParaRPr lang="en-US" sz="1400" dirty="0"/>
-          </a:p>
-          <a:p>
-            <a:pPr indent="0" marL="0">
-              <a:buNone/>
-            </a:pPr>
-            <a:r>
-              <a:rPr lang="en-US" sz="1400" dirty="0">
-                <a:solidFill>
-                  <a:srgbClr val="24313D"/>
-                </a:solidFill>
-                <a:latin typeface="Microsoft YaHei" pitchFamily="34" charset="0"/>
-                <a:ea typeface="Microsoft YaHei" pitchFamily="34" charset="-122"/>
-                <a:cs typeface="Microsoft YaHei" pitchFamily="34" charset="-120"/>
-              </a:rPr>
-              <a:t>Redis persistence with RDB and AOF</a:t>
-            </a:r>
-            <a:endParaRPr lang="en-US" sz="1400" dirty="0"/>
-          </a:p>
-          <a:p>
-            <a:pPr indent="0" marL="0">
-              <a:buNone/>
-            </a:pPr>
-            <a:r>
-              <a:rPr lang="en-US" sz="1400" dirty="0">
-                <a:solidFill>
-                  <a:srgbClr val="24313D"/>
-                </a:solidFill>
-                <a:latin typeface="Microsoft YaHei" pitchFamily="34" charset="0"/>
-                <a:ea typeface="Microsoft YaHei" pitchFamily="34" charset="-122"/>
-                <a:cs typeface="Microsoft YaHei" pitchFamily="34" charset="-120"/>
-              </a:rPr>
-              <a:t>combined_score = 1.0000</a:t>
-            </a:r>
-            <a:endParaRPr lang="en-US" sz="1400" dirty="0"/>
-          </a:p>
-        </p:txBody>
-      </p:sp>
-      <p:sp>
-        <p:nvSpPr>
-          <p:cNvPr id="12" name="Shape 10"/>
-          <p:cNvSpPr/>
-          <p:nvPr/>
-        </p:nvSpPr>
-        <p:spPr>
-          <a:xfrm>
-            <a:off x="4434840" y="2148840"/>
-            <a:ext cx="3337560" cy="2011680"/>
-          </a:xfrm>
-          <a:prstGeom prst="roundRect">
-            <a:avLst>
-              <a:gd name="adj" fmla="val 2045"/>
-            </a:avLst>
-          </a:prstGeom>
-          <a:solidFill>
-            <a:srgbClr val="FFFFFF"/>
-          </a:solidFill>
-          <a:ln w="12700">
-            <a:solidFill>
-              <a:srgbClr val="CBD5E1"/>
-            </a:solidFill>
-            <a:prstDash val="solid"/>
-          </a:ln>
-          <a:effectLst>
-            <a:outerShdw sx="100000" sy="100000" kx="0" ky="0" algn="bl" rotWithShape="0" blurRad="12700" dist="50800" dir="2700000">
-              <a:srgbClr val="D7DEE8">
-                <a:alpha val="18000"/>
-              </a:srgbClr>
-            </a:outerShdw>
-          </a:effectLst>
-        </p:spPr>
-      </p:sp>
-      <p:sp>
-        <p:nvSpPr>
-          <p:cNvPr id="13" name="Shape 11"/>
-          <p:cNvSpPr/>
-          <p:nvPr/>
-        </p:nvSpPr>
-        <p:spPr>
-          <a:xfrm>
-            <a:off x="4434840" y="2148840"/>
-            <a:ext cx="91440" cy="2011680"/>
-          </a:xfrm>
-          <a:prstGeom prst="rect">
-            <a:avLst/>
-          </a:prstGeom>
-          <a:solidFill>
-            <a:srgbClr val="0F766E"/>
-          </a:solidFill>
-          <a:ln w="12700">
-            <a:solidFill>
-              <a:srgbClr val="0F766E"/>
-            </a:solidFill>
-            <a:prstDash val="solid"/>
-          </a:ln>
-        </p:spPr>
-      </p:sp>
-      <p:sp>
-        <p:nvSpPr>
-          <p:cNvPr id="14" name="Text 12"/>
-          <p:cNvSpPr/>
-          <p:nvPr/>
-        </p:nvSpPr>
-        <p:spPr>
-          <a:xfrm>
-            <a:off x="4672584" y="2313432"/>
-            <a:ext cx="2953512" cy="256032"/>
-          </a:xfrm>
-          <a:prstGeom prst="rect">
-            <a:avLst/>
-          </a:prstGeom>
-          <a:noFill/>
-          <a:ln/>
-        </p:spPr>
-        <p:txBody>
-          <a:bodyPr wrap="square" lIns="0" tIns="0" rIns="0" bIns="0" rtlCol="0" anchor="ctr">
-            <a:normAutofit/>
-          </a:bodyPr>
-          <a:lstStyle/>
-          <a:p>
-            <a:pPr indent="0" marL="0">
-              <a:buNone/>
-            </a:pPr>
-            <a:r>
-              <a:rPr lang="en-US" sz="1600" b="1" dirty="0">
-                <a:solidFill>
-                  <a:srgbClr val="17212B"/>
-                </a:solidFill>
-                <a:latin typeface="Microsoft YaHei" pitchFamily="34" charset="0"/>
-                <a:ea typeface="Microsoft YaHei" pitchFamily="34" charset="-122"/>
-                <a:cs typeface="Microsoft YaHei" pitchFamily="34" charset="-120"/>
-              </a:rPr>
-              <a:t>答案要点</a:t>
-            </a:r>
-            <a:endParaRPr lang="en-US" sz="1600" dirty="0"/>
-          </a:p>
-        </p:txBody>
-      </p:sp>
-      <p:sp>
-        <p:nvSpPr>
-          <p:cNvPr id="15" name="Text 13"/>
-          <p:cNvSpPr/>
-          <p:nvPr/>
-        </p:nvSpPr>
-        <p:spPr>
-          <a:xfrm>
-            <a:off x="4672584" y="2715768"/>
-            <a:ext cx="2953512" cy="1298448"/>
-          </a:xfrm>
-          <a:prstGeom prst="rect">
-            <a:avLst/>
-          </a:prstGeom>
-          <a:noFill/>
-          <a:ln/>
-        </p:spPr>
-        <p:txBody>
-          <a:bodyPr wrap="square" lIns="0" tIns="0" rIns="0" bIns="0" rtlCol="0" anchor="t">
-            <a:normAutofit/>
-          </a:bodyPr>
-          <a:lstStyle/>
-          <a:p>
-            <a:pPr indent="0" marL="0">
-              <a:buNone/>
-            </a:pPr>
-            <a:r>
-              <a:rPr lang="en-US" sz="1400" dirty="0">
-                <a:solidFill>
-                  <a:srgbClr val="24313D"/>
-                </a:solidFill>
-                <a:latin typeface="Microsoft YaHei" pitchFamily="34" charset="0"/>
-                <a:ea typeface="Microsoft YaHei" pitchFamily="34" charset="-122"/>
-                <a:cs typeface="Microsoft YaHei" pitchFamily="34" charset="-120"/>
-              </a:rPr>
-              <a:t>RDB 是快照，文件紧凑，适合备份和快速恢复；AOF 是追加日志，记录写命令，数据安全性更好。</a:t>
-            </a:r>
-            <a:endParaRPr lang="en-US" sz="1400" dirty="0"/>
-          </a:p>
-        </p:txBody>
-      </p:sp>
-      <p:sp>
-        <p:nvSpPr>
-          <p:cNvPr id="16" name="Shape 14"/>
-          <p:cNvSpPr/>
-          <p:nvPr/>
-        </p:nvSpPr>
-        <p:spPr>
-          <a:xfrm>
-            <a:off x="8046720" y="2148840"/>
-            <a:ext cx="3337560" cy="2011680"/>
-          </a:xfrm>
-          <a:prstGeom prst="roundRect">
-            <a:avLst>
-              <a:gd name="adj" fmla="val 2045"/>
-            </a:avLst>
-          </a:prstGeom>
-          <a:solidFill>
-            <a:srgbClr val="FFFFFF"/>
-          </a:solidFill>
-          <a:ln w="12700">
-            <a:solidFill>
-              <a:srgbClr val="CBD5E1"/>
-            </a:solidFill>
-            <a:prstDash val="solid"/>
-          </a:ln>
-          <a:effectLst>
-            <a:outerShdw sx="100000" sy="100000" kx="0" ky="0" algn="bl" rotWithShape="0" blurRad="12700" dist="50800" dir="2700000">
-              <a:srgbClr val="D7DEE8">
-                <a:alpha val="18000"/>
-              </a:srgbClr>
-            </a:outerShdw>
-          </a:effectLst>
-        </p:spPr>
-      </p:sp>
-      <p:sp>
-        <p:nvSpPr>
-          <p:cNvPr id="17" name="Shape 15"/>
-          <p:cNvSpPr/>
-          <p:nvPr/>
-        </p:nvSpPr>
-        <p:spPr>
-          <a:xfrm>
-            <a:off x="8046720" y="2148840"/>
-            <a:ext cx="91440" cy="2011680"/>
-          </a:xfrm>
-          <a:prstGeom prst="rect">
-            <a:avLst/>
-          </a:prstGeom>
-          <a:solidFill>
-            <a:srgbClr val="F59E0B"/>
-          </a:solidFill>
-          <a:ln w="12700">
-            <a:solidFill>
-              <a:srgbClr val="F59E0B"/>
-            </a:solidFill>
-            <a:prstDash val="solid"/>
-          </a:ln>
-        </p:spPr>
-      </p:sp>
-      <p:sp>
-        <p:nvSpPr>
-          <p:cNvPr id="18" name="Text 16"/>
-          <p:cNvSpPr/>
-          <p:nvPr/>
-        </p:nvSpPr>
-        <p:spPr>
-          <a:xfrm>
-            <a:off x="8284464" y="2313432"/>
-            <a:ext cx="2953512" cy="256032"/>
-          </a:xfrm>
-          <a:prstGeom prst="rect">
-            <a:avLst/>
-          </a:prstGeom>
-          <a:noFill/>
-          <a:ln/>
-        </p:spPr>
-        <p:txBody>
-          <a:bodyPr wrap="square" lIns="0" tIns="0" rIns="0" bIns="0" rtlCol="0" anchor="ctr">
-            <a:normAutofit/>
-          </a:bodyPr>
-          <a:lstStyle/>
-          <a:p>
-            <a:pPr indent="0" marL="0">
-              <a:buNone/>
-            </a:pPr>
-            <a:r>
-              <a:rPr lang="en-US" sz="1600" b="1" dirty="0">
-                <a:solidFill>
-                  <a:srgbClr val="17212B"/>
-                </a:solidFill>
-                <a:latin typeface="Microsoft YaHei" pitchFamily="34" charset="0"/>
-                <a:ea typeface="Microsoft YaHei" pitchFamily="34" charset="-122"/>
-                <a:cs typeface="Microsoft YaHei" pitchFamily="34" charset="-120"/>
-              </a:rPr>
-              <a:t>为什么能命中</a:t>
-            </a:r>
-            <a:endParaRPr lang="en-US" sz="1600" dirty="0"/>
-          </a:p>
-        </p:txBody>
-      </p:sp>
-      <p:sp>
-        <p:nvSpPr>
-          <p:cNvPr id="19" name="Text 17"/>
-          <p:cNvSpPr/>
-          <p:nvPr/>
-        </p:nvSpPr>
-        <p:spPr>
-          <a:xfrm>
-            <a:off x="8284464" y="2715768"/>
-            <a:ext cx="2953512" cy="1298448"/>
-          </a:xfrm>
-          <a:prstGeom prst="rect">
-            <a:avLst/>
-          </a:prstGeom>
-          <a:noFill/>
-          <a:ln/>
-        </p:spPr>
-        <p:txBody>
-          <a:bodyPr wrap="square" lIns="0" tIns="0" rIns="0" bIns="0" rtlCol="0" anchor="t">
-            <a:normAutofit/>
-          </a:bodyPr>
-          <a:lstStyle/>
-          <a:p>
-            <a:pPr indent="0" marL="0">
-              <a:buNone/>
-            </a:pPr>
-            <a:r>
-              <a:rPr lang="en-US" sz="1400" dirty="0">
-                <a:solidFill>
-                  <a:srgbClr val="24313D"/>
-                </a:solidFill>
-                <a:latin typeface="Microsoft YaHei" pitchFamily="34" charset="0"/>
-                <a:ea typeface="Microsoft YaHei" pitchFamily="34" charset="-122"/>
-                <a:cs typeface="Microsoft YaHei" pitchFamily="34" charset="-120"/>
-              </a:rPr>
-              <a:t>Query Rewriting 扩展 persistence、snapshot、append only file；BM25 强命中 AOF/RDB。</a:t>
-            </a:r>
-            <a:endParaRPr lang="en-US" sz="1400" dirty="0"/>
-          </a:p>
-        </p:txBody>
-      </p:sp>
-      <p:sp>
-        <p:nvSpPr>
-          <p:cNvPr id="20" name="Text 18"/>
-          <p:cNvSpPr/>
-          <p:nvPr/>
-        </p:nvSpPr>
-        <p:spPr>
-          <a:xfrm>
-            <a:off x="868680" y="4983480"/>
-            <a:ext cx="10241280" cy="256032"/>
-          </a:xfrm>
-          <a:prstGeom prst="rect">
-            <a:avLst/>
-          </a:prstGeom>
-          <a:noFill/>
-          <a:ln/>
-        </p:spPr>
-        <p:txBody>
-          <a:bodyPr wrap="square" lIns="0" tIns="0" rIns="0" bIns="0" rtlCol="0" anchor="ctr">
-            <a:normAutofit/>
-          </a:bodyPr>
-          <a:lstStyle/>
-          <a:p>
-            <a:pPr indent="0" marL="0">
-              <a:buNone/>
-            </a:pPr>
-            <a:r>
-              <a:rPr lang="en-US" sz="1620" b="1" dirty="0">
-                <a:solidFill>
-                  <a:srgbClr val="17212B"/>
-                </a:solidFill>
-                <a:latin typeface="Microsoft YaHei" pitchFamily="34" charset="0"/>
-                <a:ea typeface="Microsoft YaHei" pitchFamily="34" charset="-122"/>
-                <a:cs typeface="Microsoft YaHei" pitchFamily="34" charset="-120"/>
-              </a:rPr>
-              <a:t>这个案例体现：Redis 问答需要同时处理中文表达、英文术语和精确命令名。</a:t>
-            </a:r>
-            <a:endParaRPr lang="en-US" sz="1620" dirty="0"/>
-          </a:p>
-        </p:txBody>
-      </p:sp>
-      <p:sp>
-        <p:nvSpPr>
-          <p:cNvPr id="21" name="Shape 19"/>
-          <p:cNvSpPr/>
-          <p:nvPr/>
-        </p:nvSpPr>
-        <p:spPr>
-          <a:xfrm>
-            <a:off x="658368" y="1901952"/>
-            <a:ext cx="10972800" cy="4370832"/>
-          </a:xfrm>
-          <a:prstGeom prst="roundRect">
-            <a:avLst>
-              <a:gd name="adj" fmla="val 837"/>
-            </a:avLst>
-          </a:prstGeom>
-          <a:solidFill>
-            <a:srgbClr val="FFFFFF"/>
-          </a:solidFill>
-          <a:ln w="12700">
-            <a:solidFill>
-              <a:srgbClr val="CBD5E1"/>
-            </a:solidFill>
-            <a:prstDash val="solid"/>
-          </a:ln>
         </p:spPr>
       </p:sp>
       <p:pic>
         <p:nvPicPr>
-          <p:cNvPr id="22" name="Image 0" descr="slides/assets/inference_result.png">    </p:cNvPr>
+          <p:cNvPr id="7" name="Image 0" descr="slides/assets/inference_result.png">    </p:cNvPr>
           <p:cNvPicPr>
             <a:picLocks noChangeAspect="1"/>
           </p:cNvPicPr>
@@ -7476,8 +4761,8 @@
         </p:blipFill>
         <p:spPr>
           <a:xfrm>
-            <a:off x="713232" y="1956816"/>
-            <a:ext cx="10863072" cy="4261104"/>
+            <a:off x="621792" y="1078992"/>
+            <a:ext cx="10936224" cy="5120640"/>
           </a:xfrm>
           <a:prstGeom prst="rect">
             <a:avLst/>
@@ -7615,7 +4900,7 @@
                 <a:ea typeface="Microsoft YaHei" pitchFamily="34" charset="-122"/>
                 <a:cs typeface="Microsoft YaHei" pitchFamily="34" charset="-120"/>
               </a:rPr>
-              <a:t>Bad Case、改进方向与总结</a:t>
+              <a:t>检索分数、Bad Case 与总结</a:t>
             </a:r>
             <a:endParaRPr lang="en-US" sz="2500" dirty="0"/>
           </a:p>
@@ -7668,12 +4953,63 @@
         </p:nvSpPr>
         <p:spPr>
           <a:xfrm>
-            <a:off x="685800" y="1143000"/>
-            <a:ext cx="3429000" cy="1828800"/>
+            <a:off x="566928" y="1024128"/>
+            <a:ext cx="11045952" cy="4261104"/>
           </a:xfrm>
           <a:prstGeom prst="roundRect">
             <a:avLst>
-              <a:gd name="adj" fmla="val 2250"/>
+              <a:gd name="adj" fmla="val 858"/>
+            </a:avLst>
+          </a:prstGeom>
+          <a:solidFill>
+            <a:srgbClr val="FFFFFF"/>
+          </a:solidFill>
+          <a:ln w="12700">
+            <a:solidFill>
+              <a:srgbClr val="CBD5E1"/>
+            </a:solidFill>
+            <a:prstDash val="solid"/>
+          </a:ln>
+        </p:spPr>
+      </p:sp>
+      <p:pic>
+        <p:nvPicPr>
+          <p:cNvPr id="7" name="Image 0" descr="slides/assets/retrieval_scores.png">    </p:cNvPr>
+          <p:cNvPicPr>
+            <a:picLocks noChangeAspect="1"/>
+          </p:cNvPicPr>
+          <p:nvPr/>
+        </p:nvPicPr>
+        <p:blipFill>
+          <a:blip r:embed="rId1"/>
+          <a:stretch>
+            <a:fillRect/>
+          </a:stretch>
+        </p:blipFill>
+        <p:spPr>
+          <a:xfrm>
+            <a:off x="621792" y="1078992"/>
+            <a:ext cx="10936224" cy="4151376"/>
+          </a:xfrm>
+          <a:prstGeom prst="rect">
+            <a:avLst/>
+          </a:prstGeom>
+        </p:spPr>
+      </p:pic>
+      <p:sp>
+        <p:nvSpPr>
+          <p:cNvPr id="8" name="Shape 5"/>
+          <p:cNvSpPr/>
+          <p:nvPr/>
+        </p:nvSpPr>
+        <p:spPr>
+          <a:xfrm>
+            <a:off x="685800" y="5468112"/>
+            <a:ext cx="3429000" cy="896112"/>
+          </a:xfrm>
+          <a:prstGeom prst="roundRect">
+            <a:avLst>
+              <a:gd name="adj" fmla="val 4592"/>
             </a:avLst>
           </a:prstGeom>
           <a:solidFill>
@@ -7696,14 +5032,14 @@
       </p:sp>
       <p:sp>
         <p:nvSpPr>
-          <p:cNvPr id="7" name="Shape 5"/>
-          <p:cNvSpPr/>
-          <p:nvPr/>
-        </p:nvSpPr>
-        <p:spPr>
-          <a:xfrm>
-            <a:off x="685800" y="1143000"/>
-            <a:ext cx="91440" cy="1828800"/>
+          <p:cNvPr id="9" name="Shape 6"/>
+          <p:cNvSpPr/>
+          <p:nvPr/>
+        </p:nvSpPr>
+        <p:spPr>
+          <a:xfrm>
+            <a:off x="685800" y="5468112"/>
+            <a:ext cx="91440" cy="896112"/>
           </a:xfrm>
           <a:prstGeom prst="rect">
             <a:avLst/>
@@ -7721,13 +5057,13 @@
       </p:sp>
       <p:sp>
         <p:nvSpPr>
-          <p:cNvPr id="8" name="Text 6"/>
-          <p:cNvSpPr/>
-          <p:nvPr/>
-        </p:nvSpPr>
-        <p:spPr>
-          <a:xfrm>
-            <a:off x="923544" y="1307592"/>
+          <p:cNvPr id="10" name="Text 7"/>
+          <p:cNvSpPr/>
+          <p:nvPr/>
+        </p:nvSpPr>
+        <p:spPr>
+          <a:xfrm>
+            <a:off x="923544" y="5632704"/>
             <a:ext cx="3044952" cy="256032"/>
           </a:xfrm>
           <a:prstGeom prst="rect">
@@ -7762,14 +5098,14 @@
       </p:sp>
       <p:sp>
         <p:nvSpPr>
-          <p:cNvPr id="9" name="Text 7"/>
-          <p:cNvSpPr/>
-          <p:nvPr/>
-        </p:nvSpPr>
-        <p:spPr>
-          <a:xfrm>
-            <a:off x="923544" y="1709928"/>
-            <a:ext cx="3044952" cy="1115568"/>
+          <p:cNvPr id="11" name="Text 8"/>
+          <p:cNvSpPr/>
+          <p:nvPr/>
+        </p:nvSpPr>
+        <p:spPr>
+          <a:xfrm>
+            <a:off x="923544" y="6035040"/>
+            <a:ext cx="3044952" cy="182880"/>
           </a:xfrm>
           <a:prstGeom prst="rect">
             <a:avLst/>
@@ -7787,7 +5123,7 @@
               <a:buNone/>
             </a:pPr>
             <a:r>
-              <a:rPr lang="en-US" sz="1350" dirty="0">
+              <a:rPr lang="en-US" sz="1220" dirty="0">
                 <a:solidFill>
                   <a:srgbClr val="24313D"/>
                 </a:solidFill>
@@ -7795,26 +5131,26 @@
                 <a:ea typeface="Microsoft YaHei" pitchFamily="34" charset="-122"/>
                 <a:cs typeface="Microsoft YaHei" pitchFamily="34" charset="-120"/>
               </a:rPr>
-              <a:t>AOF/RDB 问题早期会召回 Pub/Sub，因为 Pub/Sub 文档中也出现“不会持久化”。说明共现词会造成弱相关上下文污染。</a:t>
-            </a:r>
-            <a:endParaRPr lang="en-US" sz="1350" dirty="0"/>
-          </a:p>
-        </p:txBody>
-      </p:sp>
-      <p:sp>
-        <p:nvSpPr>
-          <p:cNvPr id="10" name="Shape 8"/>
-          <p:cNvSpPr/>
-          <p:nvPr/>
-        </p:nvSpPr>
-        <p:spPr>
-          <a:xfrm>
-            <a:off x="4389120" y="1143000"/>
-            <a:ext cx="3429000" cy="1828800"/>
+              <a:t>Pub/Sub 含“不会持久化”，容易成为弱相关召回。</a:t>
+            </a:r>
+            <a:endParaRPr lang="en-US" sz="1220" dirty="0"/>
+          </a:p>
+        </p:txBody>
+      </p:sp>
+      <p:sp>
+        <p:nvSpPr>
+          <p:cNvPr id="12" name="Shape 9"/>
+          <p:cNvSpPr/>
+          <p:nvPr/>
+        </p:nvSpPr>
+        <p:spPr>
+          <a:xfrm>
+            <a:off x="4389120" y="5468112"/>
+            <a:ext cx="3429000" cy="896112"/>
           </a:xfrm>
           <a:prstGeom prst="roundRect">
             <a:avLst>
-              <a:gd name="adj" fmla="val 2250"/>
+              <a:gd name="adj" fmla="val 4592"/>
             </a:avLst>
           </a:prstGeom>
           <a:solidFill>
@@ -7837,14 +5173,14 @@
       </p:sp>
       <p:sp>
         <p:nvSpPr>
-          <p:cNvPr id="11" name="Shape 9"/>
-          <p:cNvSpPr/>
-          <p:nvPr/>
-        </p:nvSpPr>
-        <p:spPr>
-          <a:xfrm>
-            <a:off x="4389120" y="1143000"/>
-            <a:ext cx="91440" cy="1828800"/>
+          <p:cNvPr id="13" name="Shape 10"/>
+          <p:cNvSpPr/>
+          <p:nvPr/>
+        </p:nvSpPr>
+        <p:spPr>
+          <a:xfrm>
+            <a:off x="4389120" y="5468112"/>
+            <a:ext cx="91440" cy="896112"/>
           </a:xfrm>
           <a:prstGeom prst="rect">
             <a:avLst/>
@@ -7862,13 +5198,13 @@
       </p:sp>
       <p:sp>
         <p:nvSpPr>
-          <p:cNvPr id="12" name="Text 10"/>
-          <p:cNvSpPr/>
-          <p:nvPr/>
-        </p:nvSpPr>
-        <p:spPr>
-          <a:xfrm>
-            <a:off x="4626864" y="1307592"/>
+          <p:cNvPr id="14" name="Text 11"/>
+          <p:cNvSpPr/>
+          <p:nvPr/>
+        </p:nvSpPr>
+        <p:spPr>
+          <a:xfrm>
+            <a:off x="4626864" y="5632704"/>
             <a:ext cx="3044952" cy="256032"/>
           </a:xfrm>
           <a:prstGeom prst="rect">
@@ -7903,14 +5239,14 @@
       </p:sp>
       <p:sp>
         <p:nvSpPr>
-          <p:cNvPr id="13" name="Text 11"/>
-          <p:cNvSpPr/>
-          <p:nvPr/>
-        </p:nvSpPr>
-        <p:spPr>
-          <a:xfrm>
-            <a:off x="4626864" y="1709928"/>
-            <a:ext cx="3044952" cy="1115568"/>
+          <p:cNvPr id="15" name="Text 12"/>
+          <p:cNvSpPr/>
+          <p:nvPr/>
+        </p:nvSpPr>
+        <p:spPr>
+          <a:xfrm>
+            <a:off x="4626864" y="6035040"/>
+            <a:ext cx="3044952" cy="182880"/>
           </a:xfrm>
           <a:prstGeom prst="rect">
             <a:avLst/>
@@ -7928,7 +5264,7 @@
               <a:buNone/>
             </a:pPr>
             <a:r>
-              <a:rPr lang="en-US" sz="1350" dirty="0">
+              <a:rPr lang="en-US" sz="1220" dirty="0">
                 <a:solidFill>
                   <a:srgbClr val="24313D"/>
                 </a:solidFill>
@@ -7936,26 +5272,26 @@
                 <a:ea typeface="Microsoft YaHei" pitchFamily="34" charset="-122"/>
                 <a:cs typeface="Microsoft YaHei" pitchFamily="34" charset="-120"/>
               </a:rPr>
-              <a:t>加入 Query Rewriting、BM25/Vector 融合，以及生成阶段上下文分数过滤，减少弱相关片段进入答案。</a:t>
-            </a:r>
-            <a:endParaRPr lang="en-US" sz="1350" dirty="0"/>
-          </a:p>
-        </p:txBody>
-      </p:sp>
-      <p:sp>
-        <p:nvSpPr>
-          <p:cNvPr id="14" name="Shape 12"/>
-          <p:cNvSpPr/>
-          <p:nvPr/>
-        </p:nvSpPr>
-        <p:spPr>
-          <a:xfrm>
-            <a:off x="8092440" y="1143000"/>
-            <a:ext cx="3429000" cy="1828800"/>
+              <a:t>Query Rewriting + Hybrid Retrieval + Rerank。</a:t>
+            </a:r>
+            <a:endParaRPr lang="en-US" sz="1220" dirty="0"/>
+          </a:p>
+        </p:txBody>
+      </p:sp>
+      <p:sp>
+        <p:nvSpPr>
+          <p:cNvPr id="16" name="Shape 13"/>
+          <p:cNvSpPr/>
+          <p:nvPr/>
+        </p:nvSpPr>
+        <p:spPr>
+          <a:xfrm>
+            <a:off x="8092440" y="5468112"/>
+            <a:ext cx="3429000" cy="896112"/>
           </a:xfrm>
           <a:prstGeom prst="roundRect">
             <a:avLst>
-              <a:gd name="adj" fmla="val 2250"/>
+              <a:gd name="adj" fmla="val 4592"/>
             </a:avLst>
           </a:prstGeom>
           <a:solidFill>
@@ -7978,14 +5314,14 @@
       </p:sp>
       <p:sp>
         <p:nvSpPr>
-          <p:cNvPr id="15" name="Shape 13"/>
-          <p:cNvSpPr/>
-          <p:nvPr/>
-        </p:nvSpPr>
-        <p:spPr>
-          <a:xfrm>
-            <a:off x="8092440" y="1143000"/>
-            <a:ext cx="91440" cy="1828800"/>
+          <p:cNvPr id="17" name="Shape 14"/>
+          <p:cNvSpPr/>
+          <p:nvPr/>
+        </p:nvSpPr>
+        <p:spPr>
+          <a:xfrm>
+            <a:off x="8092440" y="5468112"/>
+            <a:ext cx="91440" cy="896112"/>
           </a:xfrm>
           <a:prstGeom prst="rect">
             <a:avLst/>
@@ -8003,13 +5339,13 @@
       </p:sp>
       <p:sp>
         <p:nvSpPr>
-          <p:cNvPr id="16" name="Text 14"/>
-          <p:cNvSpPr/>
-          <p:nvPr/>
-        </p:nvSpPr>
-        <p:spPr>
-          <a:xfrm>
-            <a:off x="8330184" y="1307592"/>
+          <p:cNvPr id="18" name="Text 15"/>
+          <p:cNvSpPr/>
+          <p:nvPr/>
+        </p:nvSpPr>
+        <p:spPr>
+          <a:xfrm>
+            <a:off x="8330184" y="5632704"/>
             <a:ext cx="3044952" cy="256032"/>
           </a:xfrm>
           <a:prstGeom prst="rect">
@@ -8036,7 +5372,7 @@
                 <a:ea typeface="Microsoft YaHei" pitchFamily="34" charset="-122"/>
                 <a:cs typeface="Microsoft YaHei" pitchFamily="34" charset="-120"/>
               </a:rPr>
-              <a:t>后续优化</a:t>
+              <a:t>后续方向</a:t>
             </a:r>
             <a:endParaRPr lang="en-US" sz="1600" dirty="0"/>
           </a:p>
@@ -8044,14 +5380,14 @@
       </p:sp>
       <p:sp>
         <p:nvSpPr>
-          <p:cNvPr id="17" name="Text 15"/>
-          <p:cNvSpPr/>
-          <p:nvPr/>
-        </p:nvSpPr>
-        <p:spPr>
-          <a:xfrm>
-            <a:off x="8330184" y="1709928"/>
-            <a:ext cx="3044952" cy="1115568"/>
+          <p:cNvPr id="19" name="Text 16"/>
+          <p:cNvSpPr/>
+          <p:nvPr/>
+        </p:nvSpPr>
+        <p:spPr>
+          <a:xfrm>
+            <a:off x="8330184" y="6035040"/>
+            <a:ext cx="3044952" cy="182880"/>
           </a:xfrm>
           <a:prstGeom prst="rect">
             <a:avLst/>
@@ -8069,7 +5405,7 @@
               <a:buNone/>
             </a:pPr>
             <a:r>
-              <a:rPr lang="en-US" sz="1350" dirty="0">
+              <a:rPr lang="en-US" sz="1220" dirty="0">
                 <a:solidFill>
                   <a:srgbClr val="24313D"/>
                 </a:solidFill>
@@ -8077,225 +5413,9 @@
                 <a:ea typeface="Microsoft YaHei" pitchFamily="34" charset="-122"/>
                 <a:cs typeface="Microsoft YaHei" pitchFamily="34" charset="-120"/>
               </a:rPr>
-              <a:t>替换 BGE embedding；加入 reranker；扩展评估集；增加 LLM 生成后的 citation checking。</a:t>
-            </a:r>
-            <a:endParaRPr lang="en-US" sz="1350" dirty="0"/>
-          </a:p>
-        </p:txBody>
-      </p:sp>
-      <p:sp>
-        <p:nvSpPr>
-          <p:cNvPr id="18" name="Shape 16"/>
-          <p:cNvSpPr/>
-          <p:nvPr/>
-        </p:nvSpPr>
-        <p:spPr>
-          <a:xfrm>
-            <a:off x="822960" y="3703320"/>
-            <a:ext cx="10561320" cy="1234440"/>
-          </a:xfrm>
-          <a:prstGeom prst="roundRect">
-            <a:avLst>
-              <a:gd name="adj" fmla="val 2963"/>
-            </a:avLst>
-          </a:prstGeom>
-          <a:solidFill>
-            <a:srgbClr val="FFFFFF"/>
-          </a:solidFill>
-          <a:ln w="12700">
-            <a:solidFill>
-              <a:srgbClr val="CBD5E1"/>
-            </a:solidFill>
-            <a:prstDash val="solid"/>
-          </a:ln>
-        </p:spPr>
-      </p:sp>
-      <p:sp>
-        <p:nvSpPr>
-          <p:cNvPr id="19" name="Text 17"/>
-          <p:cNvSpPr/>
-          <p:nvPr/>
-        </p:nvSpPr>
-        <p:spPr>
-          <a:xfrm>
-            <a:off x="1097280" y="3977640"/>
-            <a:ext cx="2011680" cy="228600"/>
-          </a:xfrm>
-          <a:prstGeom prst="rect">
-            <a:avLst/>
-          </a:prstGeom>
-          <a:noFill/>
-          <a:ln/>
-        </p:spPr>
-        <p:txBody>
-          <a:bodyPr wrap="square" lIns="0" tIns="0" rIns="0" bIns="0" rtlCol="0" anchor="ctr"/>
-          <a:lstStyle/>
-          <a:p>
-            <a:pPr indent="0" marL="0">
-              <a:buNone/>
-            </a:pPr>
-            <a:r>
-              <a:rPr lang="en-US" sz="1500" b="1" dirty="0">
-                <a:solidFill>
-                  <a:srgbClr val="8A1C14"/>
-                </a:solidFill>
-                <a:latin typeface="Microsoft YaHei" pitchFamily="34" charset="0"/>
-                <a:ea typeface="Microsoft YaHei" pitchFamily="34" charset="-122"/>
-                <a:cs typeface="Microsoft YaHei" pitchFamily="34" charset="-120"/>
-              </a:rPr>
-              <a:t>复现实验命令</a:t>
-            </a:r>
-            <a:endParaRPr lang="en-US" sz="1500" dirty="0"/>
-          </a:p>
-        </p:txBody>
-      </p:sp>
-      <p:sp>
-        <p:nvSpPr>
-          <p:cNvPr id="20" name="Text 18"/>
-          <p:cNvSpPr/>
-          <p:nvPr/>
-        </p:nvSpPr>
-        <p:spPr>
-          <a:xfrm>
-            <a:off x="1097280" y="4407408"/>
-            <a:ext cx="8961120" cy="438912"/>
-          </a:xfrm>
-          <a:prstGeom prst="rect">
-            <a:avLst/>
-          </a:prstGeom>
-          <a:noFill/>
-          <a:ln/>
-        </p:spPr>
-        <p:txBody>
-          <a:bodyPr wrap="square" lIns="0" tIns="0" rIns="0" bIns="0" rtlCol="0" anchor="ctr">
-            <a:normAutofit/>
-          </a:bodyPr>
-          <a:lstStyle/>
-          <a:p>
-            <a:pPr indent="0" marL="0">
-              <a:buNone/>
-            </a:pPr>
-            <a:r>
-              <a:rPr lang="en-US" sz="1250" dirty="0">
-                <a:solidFill>
-                  <a:srgbClr val="17212B"/>
-                </a:solidFill>
-                <a:latin typeface="Courier New" pitchFamily="34" charset="0"/>
-                <a:ea typeface="Courier New" pitchFamily="34" charset="-122"/>
-                <a:cs typeface="Courier New" pitchFamily="34" charset="-120"/>
-              </a:rPr>
-              <a:t>python3 infer.py --question "Redis 的 AOF 和 RDB 持久化有什么区别？"</a:t>
-            </a:r>
-            <a:endParaRPr lang="en-US" sz="1250" dirty="0"/>
-          </a:p>
-          <a:p>
-            <a:pPr indent="0" marL="0">
-              <a:buNone/>
-            </a:pPr>
-            <a:r>
-              <a:rPr lang="en-US" sz="1250" dirty="0">
-                <a:solidFill>
-                  <a:srgbClr val="17212B"/>
-                </a:solidFill>
-                <a:latin typeface="Courier New" pitchFamily="34" charset="0"/>
-                <a:ea typeface="Courier New" pitchFamily="34" charset="-122"/>
-                <a:cs typeface="Courier New" pitchFamily="34" charset="-120"/>
-              </a:rPr>
-              <a:t>python3 evaluate.py --rebuild</a:t>
-            </a:r>
-            <a:endParaRPr lang="en-US" sz="1250" dirty="0"/>
-          </a:p>
-        </p:txBody>
-      </p:sp>
-      <p:sp>
-        <p:nvSpPr>
-          <p:cNvPr id="21" name="Shape 19"/>
-          <p:cNvSpPr/>
-          <p:nvPr/>
-        </p:nvSpPr>
-        <p:spPr>
-          <a:xfrm>
-            <a:off x="676656" y="3255264"/>
-            <a:ext cx="10881360" cy="2423160"/>
-          </a:xfrm>
-          <a:prstGeom prst="roundRect">
-            <a:avLst>
-              <a:gd name="adj" fmla="val 1509"/>
-            </a:avLst>
-          </a:prstGeom>
-          <a:solidFill>
-            <a:srgbClr val="FFFFFF"/>
-          </a:solidFill>
-          <a:ln w="12700">
-            <a:solidFill>
-              <a:srgbClr val="CBD5E1"/>
-            </a:solidFill>
-            <a:prstDash val="solid"/>
-          </a:ln>
-        </p:spPr>
-      </p:sp>
-      <p:pic>
-        <p:nvPicPr>
-          <p:cNvPr id="22" name="Image 0" descr="slides/assets/retrieval_scores.png">    </p:cNvPr>
-          <p:cNvPicPr>
-            <a:picLocks noChangeAspect="1"/>
-          </p:cNvPicPr>
-          <p:nvPr/>
-        </p:nvPicPr>
-        <p:blipFill>
-          <a:blip r:embed="rId1"/>
-          <a:stretch>
-            <a:fillRect/>
-          </a:stretch>
-        </p:blipFill>
-        <p:spPr>
-          <a:xfrm>
-            <a:off x="731520" y="3310128"/>
-            <a:ext cx="10771632" cy="2313432"/>
-          </a:xfrm>
-          <a:prstGeom prst="rect">
-            <a:avLst/>
-          </a:prstGeom>
-        </p:spPr>
-      </p:pic>
-      <p:sp>
-        <p:nvSpPr>
-          <p:cNvPr id="23" name="Text 20"/>
-          <p:cNvSpPr/>
-          <p:nvPr/>
-        </p:nvSpPr>
-        <p:spPr>
-          <a:xfrm>
-            <a:off x="868680" y="5779008"/>
-            <a:ext cx="10515600" cy="274320"/>
-          </a:xfrm>
-          <a:prstGeom prst="rect">
-            <a:avLst/>
-          </a:prstGeom>
-          <a:noFill/>
-          <a:ln/>
-        </p:spPr>
-        <p:txBody>
-          <a:bodyPr wrap="square" lIns="0" tIns="0" rIns="0" bIns="0" rtlCol="0" anchor="ctr">
-            <a:normAutofit/>
-          </a:bodyPr>
-          <a:lstStyle/>
-          <a:p>
-            <a:pPr indent="0" marL="0">
-              <a:buNone/>
-            </a:pPr>
-            <a:r>
-              <a:rPr lang="en-US" sz="1520" b="1" dirty="0">
-                <a:solidFill>
-                  <a:srgbClr val="17212B"/>
-                </a:solidFill>
-                <a:latin typeface="Microsoft YaHei" pitchFamily="34" charset="0"/>
-                <a:ea typeface="Microsoft YaHei" pitchFamily="34" charset="-122"/>
-                <a:cs typeface="Microsoft YaHei" pitchFamily="34" charset="-120"/>
-              </a:rPr>
-              <a:t>总结：本项目完成了 Redis 私有知识库、检索增强生成、DeepSeek 接入、三维评估和完整展示材料。</a:t>
-            </a:r>
-            <a:endParaRPr lang="en-US" sz="1520" dirty="0"/>
+              <a:t>BGE、FAISS/Chroma、更大评估集和 citation checking。</a:t>
+            </a:r>
+            <a:endParaRPr lang="en-US" sz="1220" dirty="0"/>
           </a:p>
         </p:txBody>
       </p:sp>
@@ -9062,7 +6182,7 @@
                 <a:ea typeface="Microsoft YaHei" pitchFamily="34" charset="-122"/>
                 <a:cs typeface="Microsoft YaHei" pitchFamily="34" charset="-120"/>
               </a:rPr>
-              <a:t>论文式报告 MD/PDF</a:t>
+              <a:t>论文式报告 MD/DOCX</a:t>
             </a:r>
             <a:endParaRPr lang="en-US" sz="1450" dirty="0"/>
           </a:p>
@@ -9096,7 +6216,7 @@
                 <a:ea typeface="Microsoft YaHei" pitchFamily="34" charset="-122"/>
                 <a:cs typeface="Microsoft YaHei" pitchFamily="34" charset="-120"/>
               </a:rPr>
-              <a:t>PPT speaker notes</a:t>
+              <a:t>演讲者备注</a:t>
             </a:r>
             <a:endParaRPr lang="en-US" sz="1450" dirty="0"/>
           </a:p>
@@ -9113,7 +6233,7 @@
                 <a:ea typeface="Microsoft YaHei" pitchFamily="34" charset="-122"/>
                 <a:cs typeface="Microsoft YaHei" pitchFamily="34" charset="-120"/>
               </a:rPr>
-              <a:t>逐页讲稿 Markdown</a:t>
+              <a:t>可直接朗读讲稿</a:t>
             </a:r>
             <a:endParaRPr lang="en-US" sz="1450" dirty="0"/>
           </a:p>
@@ -11180,12 +8300,12 @@
         </p:nvSpPr>
         <p:spPr>
           <a:xfrm>
-            <a:off x="777240" y="1188720"/>
-            <a:ext cx="4983480" cy="1060704"/>
+            <a:off x="658368" y="1078992"/>
+            <a:ext cx="10927080" cy="5285232"/>
           </a:xfrm>
           <a:prstGeom prst="roundRect">
             <a:avLst>
-              <a:gd name="adj" fmla="val 3879"/>
+              <a:gd name="adj" fmla="val 692"/>
             </a:avLst>
           </a:prstGeom>
           <a:solidFill>
@@ -11197,925 +8317,11 @@
             </a:solidFill>
             <a:prstDash val="solid"/>
           </a:ln>
-          <a:effectLst>
-            <a:outerShdw sx="100000" sy="100000" kx="0" ky="0" algn="bl" rotWithShape="0" blurRad="12700" dist="50800" dir="2700000">
-              <a:srgbClr val="D7DEE8">
-                <a:alpha val="18000"/>
-              </a:srgbClr>
-            </a:outerShdw>
-          </a:effectLst>
-        </p:spPr>
-      </p:sp>
-      <p:sp>
-        <p:nvSpPr>
-          <p:cNvPr id="7" name="Shape 5"/>
-          <p:cNvSpPr/>
-          <p:nvPr/>
-        </p:nvSpPr>
-        <p:spPr>
-          <a:xfrm>
-            <a:off x="777240" y="1188720"/>
-            <a:ext cx="91440" cy="1060704"/>
-          </a:xfrm>
-          <a:prstGeom prst="rect">
-            <a:avLst/>
-          </a:prstGeom>
-          <a:solidFill>
-            <a:srgbClr val="D92D20"/>
-          </a:solidFill>
-          <a:ln w="12700">
-            <a:solidFill>
-              <a:srgbClr val="D92D20"/>
-            </a:solidFill>
-            <a:prstDash val="solid"/>
-          </a:ln>
-        </p:spPr>
-      </p:sp>
-      <p:sp>
-        <p:nvSpPr>
-          <p:cNvPr id="8" name="Text 6"/>
-          <p:cNvSpPr/>
-          <p:nvPr/>
-        </p:nvSpPr>
-        <p:spPr>
-          <a:xfrm>
-            <a:off x="1014984" y="1353312"/>
-            <a:ext cx="4599432" cy="256032"/>
-          </a:xfrm>
-          <a:prstGeom prst="rect">
-            <a:avLst/>
-          </a:prstGeom>
-          <a:noFill/>
-          <a:ln/>
-        </p:spPr>
-        <p:txBody>
-          <a:bodyPr wrap="square" lIns="0" tIns="0" rIns="0" bIns="0" rtlCol="0" anchor="ctr">
-            <a:normAutofit/>
-          </a:bodyPr>
-          <a:lstStyle/>
-          <a:p>
-            <a:pPr indent="0" marL="0">
-              <a:buNone/>
-            </a:pPr>
-            <a:r>
-              <a:rPr lang="en-US" sz="1600" b="1" dirty="0">
-                <a:solidFill>
-                  <a:srgbClr val="17212B"/>
-                </a:solidFill>
-                <a:latin typeface="Microsoft YaHei" pitchFamily="34" charset="0"/>
-                <a:ea typeface="Microsoft YaHei" pitchFamily="34" charset="-122"/>
-                <a:cs typeface="Microsoft YaHei" pitchFamily="34" charset="-120"/>
-              </a:rPr>
-              <a:t>基础数据结构</a:t>
-            </a:r>
-            <a:endParaRPr lang="en-US" sz="1600" dirty="0"/>
-          </a:p>
-        </p:txBody>
-      </p:sp>
-      <p:sp>
-        <p:nvSpPr>
-          <p:cNvPr id="9" name="Text 7"/>
-          <p:cNvSpPr/>
-          <p:nvPr/>
-        </p:nvSpPr>
-        <p:spPr>
-          <a:xfrm>
-            <a:off x="1014984" y="1755648"/>
-            <a:ext cx="4599432" cy="347472"/>
-          </a:xfrm>
-          <a:prstGeom prst="rect">
-            <a:avLst/>
-          </a:prstGeom>
-          <a:noFill/>
-          <a:ln/>
-        </p:spPr>
-        <p:txBody>
-          <a:bodyPr wrap="square" lIns="0" tIns="0" rIns="0" bIns="0" rtlCol="0" anchor="t">
-            <a:normAutofit/>
-          </a:bodyPr>
-          <a:lstStyle/>
-          <a:p>
-            <a:pPr indent="0" marL="0">
-              <a:buNone/>
-            </a:pPr>
-            <a:r>
-              <a:rPr lang="en-US" sz="1420" dirty="0">
-                <a:solidFill>
-                  <a:srgbClr val="24313D"/>
-                </a:solidFill>
-                <a:latin typeface="Microsoft YaHei" pitchFamily="34" charset="0"/>
-                <a:ea typeface="Microsoft YaHei" pitchFamily="34" charset="-122"/>
-                <a:cs typeface="Microsoft YaHei" pitchFamily="34" charset="-120"/>
-              </a:rPr>
-              <a:t>String / Hash / List / Stream / Sorted Set</a:t>
-            </a:r>
-            <a:endParaRPr lang="en-US" sz="1420" dirty="0"/>
-          </a:p>
-        </p:txBody>
-      </p:sp>
-      <p:sp>
-        <p:nvSpPr>
-          <p:cNvPr id="10" name="Shape 8"/>
-          <p:cNvSpPr/>
-          <p:nvPr/>
-        </p:nvSpPr>
-        <p:spPr>
-          <a:xfrm>
-            <a:off x="6309360" y="1188720"/>
-            <a:ext cx="4983480" cy="1060704"/>
-          </a:xfrm>
-          <a:prstGeom prst="roundRect">
-            <a:avLst>
-              <a:gd name="adj" fmla="val 3879"/>
-            </a:avLst>
-          </a:prstGeom>
-          <a:solidFill>
-            <a:srgbClr val="FFFFFF"/>
-          </a:solidFill>
-          <a:ln w="12700">
-            <a:solidFill>
-              <a:srgbClr val="CBD5E1"/>
-            </a:solidFill>
-            <a:prstDash val="solid"/>
-          </a:ln>
-          <a:effectLst>
-            <a:outerShdw sx="100000" sy="100000" kx="0" ky="0" algn="bl" rotWithShape="0" blurRad="12700" dist="50800" dir="2700000">
-              <a:srgbClr val="D7DEE8">
-                <a:alpha val="18000"/>
-              </a:srgbClr>
-            </a:outerShdw>
-          </a:effectLst>
-        </p:spPr>
-      </p:sp>
-      <p:sp>
-        <p:nvSpPr>
-          <p:cNvPr id="11" name="Shape 9"/>
-          <p:cNvSpPr/>
-          <p:nvPr/>
-        </p:nvSpPr>
-        <p:spPr>
-          <a:xfrm>
-            <a:off x="6309360" y="1188720"/>
-            <a:ext cx="91440" cy="1060704"/>
-          </a:xfrm>
-          <a:prstGeom prst="rect">
-            <a:avLst/>
-          </a:prstGeom>
-          <a:solidFill>
-            <a:srgbClr val="0F766E"/>
-          </a:solidFill>
-          <a:ln w="12700">
-            <a:solidFill>
-              <a:srgbClr val="0F766E"/>
-            </a:solidFill>
-            <a:prstDash val="solid"/>
-          </a:ln>
-        </p:spPr>
-      </p:sp>
-      <p:sp>
-        <p:nvSpPr>
-          <p:cNvPr id="12" name="Text 10"/>
-          <p:cNvSpPr/>
-          <p:nvPr/>
-        </p:nvSpPr>
-        <p:spPr>
-          <a:xfrm>
-            <a:off x="6547104" y="1353312"/>
-            <a:ext cx="4599432" cy="256032"/>
-          </a:xfrm>
-          <a:prstGeom prst="rect">
-            <a:avLst/>
-          </a:prstGeom>
-          <a:noFill/>
-          <a:ln/>
-        </p:spPr>
-        <p:txBody>
-          <a:bodyPr wrap="square" lIns="0" tIns="0" rIns="0" bIns="0" rtlCol="0" anchor="ctr">
-            <a:normAutofit/>
-          </a:bodyPr>
-          <a:lstStyle/>
-          <a:p>
-            <a:pPr indent="0" marL="0">
-              <a:buNone/>
-            </a:pPr>
-            <a:r>
-              <a:rPr lang="en-US" sz="1600" b="1" dirty="0">
-                <a:solidFill>
-                  <a:srgbClr val="17212B"/>
-                </a:solidFill>
-                <a:latin typeface="Microsoft YaHei" pitchFamily="34" charset="0"/>
-                <a:ea typeface="Microsoft YaHei" pitchFamily="34" charset="-122"/>
-                <a:cs typeface="Microsoft YaHei" pitchFamily="34" charset="-120"/>
-              </a:rPr>
-              <a:t>生命周期</a:t>
-            </a:r>
-            <a:endParaRPr lang="en-US" sz="1600" dirty="0"/>
-          </a:p>
-        </p:txBody>
-      </p:sp>
-      <p:sp>
-        <p:nvSpPr>
-          <p:cNvPr id="13" name="Text 11"/>
-          <p:cNvSpPr/>
-          <p:nvPr/>
-        </p:nvSpPr>
-        <p:spPr>
-          <a:xfrm>
-            <a:off x="6547104" y="1755648"/>
-            <a:ext cx="4599432" cy="347472"/>
-          </a:xfrm>
-          <a:prstGeom prst="rect">
-            <a:avLst/>
-          </a:prstGeom>
-          <a:noFill/>
-          <a:ln/>
-        </p:spPr>
-        <p:txBody>
-          <a:bodyPr wrap="square" lIns="0" tIns="0" rIns="0" bIns="0" rtlCol="0" anchor="t">
-            <a:normAutofit/>
-          </a:bodyPr>
-          <a:lstStyle/>
-          <a:p>
-            <a:pPr indent="0" marL="0">
-              <a:buNone/>
-            </a:pPr>
-            <a:r>
-              <a:rPr lang="en-US" sz="1420" dirty="0">
-                <a:solidFill>
-                  <a:srgbClr val="24313D"/>
-                </a:solidFill>
-                <a:latin typeface="Microsoft YaHei" pitchFamily="34" charset="0"/>
-                <a:ea typeface="Microsoft YaHei" pitchFamily="34" charset="-122"/>
-                <a:cs typeface="Microsoft YaHei" pitchFamily="34" charset="-120"/>
-              </a:rPr>
-              <a:t>EXPIRE / TTL / PERSIST / 惰性删除 / 周期删除</a:t>
-            </a:r>
-            <a:endParaRPr lang="en-US" sz="1420" dirty="0"/>
-          </a:p>
-        </p:txBody>
-      </p:sp>
-      <p:sp>
-        <p:nvSpPr>
-          <p:cNvPr id="14" name="Shape 12"/>
-          <p:cNvSpPr/>
-          <p:nvPr/>
-        </p:nvSpPr>
-        <p:spPr>
-          <a:xfrm>
-            <a:off x="777240" y="2606040"/>
-            <a:ext cx="4983480" cy="1060704"/>
-          </a:xfrm>
-          <a:prstGeom prst="roundRect">
-            <a:avLst>
-              <a:gd name="adj" fmla="val 3879"/>
-            </a:avLst>
-          </a:prstGeom>
-          <a:solidFill>
-            <a:srgbClr val="FFFFFF"/>
-          </a:solidFill>
-          <a:ln w="12700">
-            <a:solidFill>
-              <a:srgbClr val="CBD5E1"/>
-            </a:solidFill>
-            <a:prstDash val="solid"/>
-          </a:ln>
-          <a:effectLst>
-            <a:outerShdw sx="100000" sy="100000" kx="0" ky="0" algn="bl" rotWithShape="0" blurRad="12700" dist="50800" dir="2700000">
-              <a:srgbClr val="D7DEE8">
-                <a:alpha val="18000"/>
-              </a:srgbClr>
-            </a:outerShdw>
-          </a:effectLst>
-        </p:spPr>
-      </p:sp>
-      <p:sp>
-        <p:nvSpPr>
-          <p:cNvPr id="15" name="Shape 13"/>
-          <p:cNvSpPr/>
-          <p:nvPr/>
-        </p:nvSpPr>
-        <p:spPr>
-          <a:xfrm>
-            <a:off x="777240" y="2606040"/>
-            <a:ext cx="91440" cy="1060704"/>
-          </a:xfrm>
-          <a:prstGeom prst="rect">
-            <a:avLst/>
-          </a:prstGeom>
-          <a:solidFill>
-            <a:srgbClr val="D92D20"/>
-          </a:solidFill>
-          <a:ln w="12700">
-            <a:solidFill>
-              <a:srgbClr val="D92D20"/>
-            </a:solidFill>
-            <a:prstDash val="solid"/>
-          </a:ln>
-        </p:spPr>
-      </p:sp>
-      <p:sp>
-        <p:nvSpPr>
-          <p:cNvPr id="16" name="Text 14"/>
-          <p:cNvSpPr/>
-          <p:nvPr/>
-        </p:nvSpPr>
-        <p:spPr>
-          <a:xfrm>
-            <a:off x="1014984" y="2770632"/>
-            <a:ext cx="4599432" cy="256032"/>
-          </a:xfrm>
-          <a:prstGeom prst="rect">
-            <a:avLst/>
-          </a:prstGeom>
-          <a:noFill/>
-          <a:ln/>
-        </p:spPr>
-        <p:txBody>
-          <a:bodyPr wrap="square" lIns="0" tIns="0" rIns="0" bIns="0" rtlCol="0" anchor="ctr">
-            <a:normAutofit/>
-          </a:bodyPr>
-          <a:lstStyle/>
-          <a:p>
-            <a:pPr indent="0" marL="0">
-              <a:buNone/>
-            </a:pPr>
-            <a:r>
-              <a:rPr lang="en-US" sz="1600" b="1" dirty="0">
-                <a:solidFill>
-                  <a:srgbClr val="17212B"/>
-                </a:solidFill>
-                <a:latin typeface="Microsoft YaHei" pitchFamily="34" charset="0"/>
-                <a:ea typeface="Microsoft YaHei" pitchFamily="34" charset="-122"/>
-                <a:cs typeface="Microsoft YaHei" pitchFamily="34" charset="-120"/>
-              </a:rPr>
-              <a:t>可靠性</a:t>
-            </a:r>
-            <a:endParaRPr lang="en-US" sz="1600" dirty="0"/>
-          </a:p>
-        </p:txBody>
-      </p:sp>
-      <p:sp>
-        <p:nvSpPr>
-          <p:cNvPr id="17" name="Text 15"/>
-          <p:cNvSpPr/>
-          <p:nvPr/>
-        </p:nvSpPr>
-        <p:spPr>
-          <a:xfrm>
-            <a:off x="1014984" y="3172968"/>
-            <a:ext cx="4599432" cy="347472"/>
-          </a:xfrm>
-          <a:prstGeom prst="rect">
-            <a:avLst/>
-          </a:prstGeom>
-          <a:noFill/>
-          <a:ln/>
-        </p:spPr>
-        <p:txBody>
-          <a:bodyPr wrap="square" lIns="0" tIns="0" rIns="0" bIns="0" rtlCol="0" anchor="t">
-            <a:normAutofit/>
-          </a:bodyPr>
-          <a:lstStyle/>
-          <a:p>
-            <a:pPr indent="0" marL="0">
-              <a:buNone/>
-            </a:pPr>
-            <a:r>
-              <a:rPr lang="en-US" sz="1420" dirty="0">
-                <a:solidFill>
-                  <a:srgbClr val="24313D"/>
-                </a:solidFill>
-                <a:latin typeface="Microsoft YaHei" pitchFamily="34" charset="0"/>
-                <a:ea typeface="Microsoft YaHei" pitchFamily="34" charset="-122"/>
-                <a:cs typeface="Microsoft YaHei" pitchFamily="34" charset="-120"/>
-              </a:rPr>
-              <a:t>RDB / AOF / appendfsync / 备份恢复</a:t>
-            </a:r>
-            <a:endParaRPr lang="en-US" sz="1420" dirty="0"/>
-          </a:p>
-        </p:txBody>
-      </p:sp>
-      <p:sp>
-        <p:nvSpPr>
-          <p:cNvPr id="18" name="Shape 16"/>
-          <p:cNvSpPr/>
-          <p:nvPr/>
-        </p:nvSpPr>
-        <p:spPr>
-          <a:xfrm>
-            <a:off x="6309360" y="2606040"/>
-            <a:ext cx="4983480" cy="1060704"/>
-          </a:xfrm>
-          <a:prstGeom prst="roundRect">
-            <a:avLst>
-              <a:gd name="adj" fmla="val 3879"/>
-            </a:avLst>
-          </a:prstGeom>
-          <a:solidFill>
-            <a:srgbClr val="FFFFFF"/>
-          </a:solidFill>
-          <a:ln w="12700">
-            <a:solidFill>
-              <a:srgbClr val="CBD5E1"/>
-            </a:solidFill>
-            <a:prstDash val="solid"/>
-          </a:ln>
-          <a:effectLst>
-            <a:outerShdw sx="100000" sy="100000" kx="0" ky="0" algn="bl" rotWithShape="0" blurRad="12700" dist="50800" dir="2700000">
-              <a:srgbClr val="D7DEE8">
-                <a:alpha val="18000"/>
-              </a:srgbClr>
-            </a:outerShdw>
-          </a:effectLst>
-        </p:spPr>
-      </p:sp>
-      <p:sp>
-        <p:nvSpPr>
-          <p:cNvPr id="19" name="Shape 17"/>
-          <p:cNvSpPr/>
-          <p:nvPr/>
-        </p:nvSpPr>
-        <p:spPr>
-          <a:xfrm>
-            <a:off x="6309360" y="2606040"/>
-            <a:ext cx="91440" cy="1060704"/>
-          </a:xfrm>
-          <a:prstGeom prst="rect">
-            <a:avLst/>
-          </a:prstGeom>
-          <a:solidFill>
-            <a:srgbClr val="0F766E"/>
-          </a:solidFill>
-          <a:ln w="12700">
-            <a:solidFill>
-              <a:srgbClr val="0F766E"/>
-            </a:solidFill>
-            <a:prstDash val="solid"/>
-          </a:ln>
-        </p:spPr>
-      </p:sp>
-      <p:sp>
-        <p:nvSpPr>
-          <p:cNvPr id="20" name="Text 18"/>
-          <p:cNvSpPr/>
-          <p:nvPr/>
-        </p:nvSpPr>
-        <p:spPr>
-          <a:xfrm>
-            <a:off x="6547104" y="2770632"/>
-            <a:ext cx="4599432" cy="256032"/>
-          </a:xfrm>
-          <a:prstGeom prst="rect">
-            <a:avLst/>
-          </a:prstGeom>
-          <a:noFill/>
-          <a:ln/>
-        </p:spPr>
-        <p:txBody>
-          <a:bodyPr wrap="square" lIns="0" tIns="0" rIns="0" bIns="0" rtlCol="0" anchor="ctr">
-            <a:normAutofit/>
-          </a:bodyPr>
-          <a:lstStyle/>
-          <a:p>
-            <a:pPr indent="0" marL="0">
-              <a:buNone/>
-            </a:pPr>
-            <a:r>
-              <a:rPr lang="en-US" sz="1600" b="1" dirty="0">
-                <a:solidFill>
-                  <a:srgbClr val="17212B"/>
-                </a:solidFill>
-                <a:latin typeface="Microsoft YaHei" pitchFamily="34" charset="0"/>
-                <a:ea typeface="Microsoft YaHei" pitchFamily="34" charset="-122"/>
-                <a:cs typeface="Microsoft YaHei" pitchFamily="34" charset="-120"/>
-              </a:rPr>
-              <a:t>高可用与扩展</a:t>
-            </a:r>
-            <a:endParaRPr lang="en-US" sz="1600" dirty="0"/>
-          </a:p>
-        </p:txBody>
-      </p:sp>
-      <p:sp>
-        <p:nvSpPr>
-          <p:cNvPr id="21" name="Text 19"/>
-          <p:cNvSpPr/>
-          <p:nvPr/>
-        </p:nvSpPr>
-        <p:spPr>
-          <a:xfrm>
-            <a:off x="6547104" y="3172968"/>
-            <a:ext cx="4599432" cy="347472"/>
-          </a:xfrm>
-          <a:prstGeom prst="rect">
-            <a:avLst/>
-          </a:prstGeom>
-          <a:noFill/>
-          <a:ln/>
-        </p:spPr>
-        <p:txBody>
-          <a:bodyPr wrap="square" lIns="0" tIns="0" rIns="0" bIns="0" rtlCol="0" anchor="t">
-            <a:normAutofit/>
-          </a:bodyPr>
-          <a:lstStyle/>
-          <a:p>
-            <a:pPr indent="0" marL="0">
-              <a:buNone/>
-            </a:pPr>
-            <a:r>
-              <a:rPr lang="en-US" sz="1420" dirty="0">
-                <a:solidFill>
-                  <a:srgbClr val="24313D"/>
-                </a:solidFill>
-                <a:latin typeface="Microsoft YaHei" pitchFamily="34" charset="0"/>
-                <a:ea typeface="Microsoft YaHei" pitchFamily="34" charset="-122"/>
-                <a:cs typeface="Microsoft YaHei" pitchFamily="34" charset="-120"/>
-              </a:rPr>
-              <a:t>Replication / Sentinel / Cluster / hash slot</a:t>
-            </a:r>
-            <a:endParaRPr lang="en-US" sz="1420" dirty="0"/>
-          </a:p>
-        </p:txBody>
-      </p:sp>
-      <p:sp>
-        <p:nvSpPr>
-          <p:cNvPr id="22" name="Shape 20"/>
-          <p:cNvSpPr/>
-          <p:nvPr/>
-        </p:nvSpPr>
-        <p:spPr>
-          <a:xfrm>
-            <a:off x="777240" y="4023360"/>
-            <a:ext cx="4983480" cy="1060704"/>
-          </a:xfrm>
-          <a:prstGeom prst="roundRect">
-            <a:avLst>
-              <a:gd name="adj" fmla="val 3879"/>
-            </a:avLst>
-          </a:prstGeom>
-          <a:solidFill>
-            <a:srgbClr val="FFFFFF"/>
-          </a:solidFill>
-          <a:ln w="12700">
-            <a:solidFill>
-              <a:srgbClr val="CBD5E1"/>
-            </a:solidFill>
-            <a:prstDash val="solid"/>
-          </a:ln>
-          <a:effectLst>
-            <a:outerShdw sx="100000" sy="100000" kx="0" ky="0" algn="bl" rotWithShape="0" blurRad="12700" dist="50800" dir="2700000">
-              <a:srgbClr val="D7DEE8">
-                <a:alpha val="18000"/>
-              </a:srgbClr>
-            </a:outerShdw>
-          </a:effectLst>
-        </p:spPr>
-      </p:sp>
-      <p:sp>
-        <p:nvSpPr>
-          <p:cNvPr id="23" name="Shape 21"/>
-          <p:cNvSpPr/>
-          <p:nvPr/>
-        </p:nvSpPr>
-        <p:spPr>
-          <a:xfrm>
-            <a:off x="777240" y="4023360"/>
-            <a:ext cx="91440" cy="1060704"/>
-          </a:xfrm>
-          <a:prstGeom prst="rect">
-            <a:avLst/>
-          </a:prstGeom>
-          <a:solidFill>
-            <a:srgbClr val="D92D20"/>
-          </a:solidFill>
-          <a:ln w="12700">
-            <a:solidFill>
-              <a:srgbClr val="D92D20"/>
-            </a:solidFill>
-            <a:prstDash val="solid"/>
-          </a:ln>
-        </p:spPr>
-      </p:sp>
-      <p:sp>
-        <p:nvSpPr>
-          <p:cNvPr id="24" name="Text 22"/>
-          <p:cNvSpPr/>
-          <p:nvPr/>
-        </p:nvSpPr>
-        <p:spPr>
-          <a:xfrm>
-            <a:off x="1014984" y="4187952"/>
-            <a:ext cx="4599432" cy="256032"/>
-          </a:xfrm>
-          <a:prstGeom prst="rect">
-            <a:avLst/>
-          </a:prstGeom>
-          <a:noFill/>
-          <a:ln/>
-        </p:spPr>
-        <p:txBody>
-          <a:bodyPr wrap="square" lIns="0" tIns="0" rIns="0" bIns="0" rtlCol="0" anchor="ctr">
-            <a:normAutofit/>
-          </a:bodyPr>
-          <a:lstStyle/>
-          <a:p>
-            <a:pPr indent="0" marL="0">
-              <a:buNone/>
-            </a:pPr>
-            <a:r>
-              <a:rPr lang="en-US" sz="1600" b="1" dirty="0">
-                <a:solidFill>
-                  <a:srgbClr val="17212B"/>
-                </a:solidFill>
-                <a:latin typeface="Microsoft YaHei" pitchFamily="34" charset="0"/>
-                <a:ea typeface="Microsoft YaHei" pitchFamily="34" charset="-122"/>
-                <a:cs typeface="Microsoft YaHei" pitchFamily="34" charset="-120"/>
-              </a:rPr>
-              <a:t>编程与消息</a:t>
-            </a:r>
-            <a:endParaRPr lang="en-US" sz="1600" dirty="0"/>
-          </a:p>
-        </p:txBody>
-      </p:sp>
-      <p:sp>
-        <p:nvSpPr>
-          <p:cNvPr id="25" name="Text 23"/>
-          <p:cNvSpPr/>
-          <p:nvPr/>
-        </p:nvSpPr>
-        <p:spPr>
-          <a:xfrm>
-            <a:off x="1014984" y="4590288"/>
-            <a:ext cx="4599432" cy="347472"/>
-          </a:xfrm>
-          <a:prstGeom prst="rect">
-            <a:avLst/>
-          </a:prstGeom>
-          <a:noFill/>
-          <a:ln/>
-        </p:spPr>
-        <p:txBody>
-          <a:bodyPr wrap="square" lIns="0" tIns="0" rIns="0" bIns="0" rtlCol="0" anchor="t">
-            <a:normAutofit/>
-          </a:bodyPr>
-          <a:lstStyle/>
-          <a:p>
-            <a:pPr indent="0" marL="0">
-              <a:buNone/>
-            </a:pPr>
-            <a:r>
-              <a:rPr lang="en-US" sz="1420" dirty="0">
-                <a:solidFill>
-                  <a:srgbClr val="24313D"/>
-                </a:solidFill>
-                <a:latin typeface="Microsoft YaHei" pitchFamily="34" charset="0"/>
-                <a:ea typeface="Microsoft YaHei" pitchFamily="34" charset="-122"/>
-                <a:cs typeface="Microsoft YaHei" pitchFamily="34" charset="-120"/>
-              </a:rPr>
-              <a:t>MULTI / EXEC / WATCH / Lua / Pub/Sub / Stream</a:t>
-            </a:r>
-            <a:endParaRPr lang="en-US" sz="1420" dirty="0"/>
-          </a:p>
-        </p:txBody>
-      </p:sp>
-      <p:sp>
-        <p:nvSpPr>
-          <p:cNvPr id="26" name="Shape 24"/>
-          <p:cNvSpPr/>
-          <p:nvPr/>
-        </p:nvSpPr>
-        <p:spPr>
-          <a:xfrm>
-            <a:off x="6309360" y="4023360"/>
-            <a:ext cx="4983480" cy="1060704"/>
-          </a:xfrm>
-          <a:prstGeom prst="roundRect">
-            <a:avLst>
-              <a:gd name="adj" fmla="val 3879"/>
-            </a:avLst>
-          </a:prstGeom>
-          <a:solidFill>
-            <a:srgbClr val="FFFFFF"/>
-          </a:solidFill>
-          <a:ln w="12700">
-            <a:solidFill>
-              <a:srgbClr val="CBD5E1"/>
-            </a:solidFill>
-            <a:prstDash val="solid"/>
-          </a:ln>
-          <a:effectLst>
-            <a:outerShdw sx="100000" sy="100000" kx="0" ky="0" algn="bl" rotWithShape="0" blurRad="12700" dist="50800" dir="2700000">
-              <a:srgbClr val="D7DEE8">
-                <a:alpha val="18000"/>
-              </a:srgbClr>
-            </a:outerShdw>
-          </a:effectLst>
-        </p:spPr>
-      </p:sp>
-      <p:sp>
-        <p:nvSpPr>
-          <p:cNvPr id="27" name="Shape 25"/>
-          <p:cNvSpPr/>
-          <p:nvPr/>
-        </p:nvSpPr>
-        <p:spPr>
-          <a:xfrm>
-            <a:off x="6309360" y="4023360"/>
-            <a:ext cx="91440" cy="1060704"/>
-          </a:xfrm>
-          <a:prstGeom prst="rect">
-            <a:avLst/>
-          </a:prstGeom>
-          <a:solidFill>
-            <a:srgbClr val="0F766E"/>
-          </a:solidFill>
-          <a:ln w="12700">
-            <a:solidFill>
-              <a:srgbClr val="0F766E"/>
-            </a:solidFill>
-            <a:prstDash val="solid"/>
-          </a:ln>
-        </p:spPr>
-      </p:sp>
-      <p:sp>
-        <p:nvSpPr>
-          <p:cNvPr id="28" name="Text 26"/>
-          <p:cNvSpPr/>
-          <p:nvPr/>
-        </p:nvSpPr>
-        <p:spPr>
-          <a:xfrm>
-            <a:off x="6547104" y="4187952"/>
-            <a:ext cx="4599432" cy="256032"/>
-          </a:xfrm>
-          <a:prstGeom prst="rect">
-            <a:avLst/>
-          </a:prstGeom>
-          <a:noFill/>
-          <a:ln/>
-        </p:spPr>
-        <p:txBody>
-          <a:bodyPr wrap="square" lIns="0" tIns="0" rIns="0" bIns="0" rtlCol="0" anchor="ctr">
-            <a:normAutofit/>
-          </a:bodyPr>
-          <a:lstStyle/>
-          <a:p>
-            <a:pPr indent="0" marL="0">
-              <a:buNone/>
-            </a:pPr>
-            <a:r>
-              <a:rPr lang="en-US" sz="1600" b="1" dirty="0">
-                <a:solidFill>
-                  <a:srgbClr val="17212B"/>
-                </a:solidFill>
-                <a:latin typeface="Microsoft YaHei" pitchFamily="34" charset="0"/>
-                <a:ea typeface="Microsoft YaHei" pitchFamily="34" charset="-122"/>
-                <a:cs typeface="Microsoft YaHei" pitchFamily="34" charset="-120"/>
-              </a:rPr>
-              <a:t>缓存工程</a:t>
-            </a:r>
-            <a:endParaRPr lang="en-US" sz="1600" dirty="0"/>
-          </a:p>
-        </p:txBody>
-      </p:sp>
-      <p:sp>
-        <p:nvSpPr>
-          <p:cNvPr id="29" name="Text 27"/>
-          <p:cNvSpPr/>
-          <p:nvPr/>
-        </p:nvSpPr>
-        <p:spPr>
-          <a:xfrm>
-            <a:off x="6547104" y="4590288"/>
-            <a:ext cx="4599432" cy="347472"/>
-          </a:xfrm>
-          <a:prstGeom prst="rect">
-            <a:avLst/>
-          </a:prstGeom>
-          <a:noFill/>
-          <a:ln/>
-        </p:spPr>
-        <p:txBody>
-          <a:bodyPr wrap="square" lIns="0" tIns="0" rIns="0" bIns="0" rtlCol="0" anchor="t">
-            <a:normAutofit/>
-          </a:bodyPr>
-          <a:lstStyle/>
-          <a:p>
-            <a:pPr indent="0" marL="0">
-              <a:buNone/>
-            </a:pPr>
-            <a:r>
-              <a:rPr lang="en-US" sz="1420" dirty="0">
-                <a:solidFill>
-                  <a:srgbClr val="24313D"/>
-                </a:solidFill>
-                <a:latin typeface="Microsoft YaHei" pitchFamily="34" charset="0"/>
-                <a:ea typeface="Microsoft YaHei" pitchFamily="34" charset="-122"/>
-                <a:cs typeface="Microsoft YaHei" pitchFamily="34" charset="-120"/>
-              </a:rPr>
-              <a:t>缓存穿透 / 缓存击穿 / 缓存雪崩 / 随机 TTL</a:t>
-            </a:r>
-            <a:endParaRPr lang="en-US" sz="1420" dirty="0"/>
-          </a:p>
-        </p:txBody>
-      </p:sp>
-      <p:sp>
-        <p:nvSpPr>
-          <p:cNvPr id="30" name="Shape 28"/>
-          <p:cNvSpPr/>
-          <p:nvPr/>
-        </p:nvSpPr>
-        <p:spPr>
-          <a:xfrm>
-            <a:off x="868680" y="5577840"/>
-            <a:ext cx="10424160" cy="475488"/>
-          </a:xfrm>
-          <a:prstGeom prst="roundRect">
-            <a:avLst>
-              <a:gd name="adj" fmla="val 7692"/>
-            </a:avLst>
-          </a:prstGeom>
-          <a:solidFill>
-            <a:srgbClr val="FDE8E5"/>
-          </a:solidFill>
-          <a:ln w="12700">
-            <a:solidFill>
-              <a:srgbClr val="F8C5BD"/>
-            </a:solidFill>
-            <a:prstDash val="solid"/>
-          </a:ln>
-        </p:spPr>
-      </p:sp>
-      <p:sp>
-        <p:nvSpPr>
-          <p:cNvPr id="31" name="Text 29"/>
-          <p:cNvSpPr/>
-          <p:nvPr/>
-        </p:nvSpPr>
-        <p:spPr>
-          <a:xfrm>
-            <a:off x="1097280" y="5715000"/>
-            <a:ext cx="9966960" cy="182880"/>
-          </a:xfrm>
-          <a:prstGeom prst="rect">
-            <a:avLst/>
-          </a:prstGeom>
-          <a:noFill/>
-          <a:ln/>
-        </p:spPr>
-        <p:txBody>
-          <a:bodyPr wrap="square" lIns="0" tIns="0" rIns="0" bIns="0" rtlCol="0" anchor="ctr">
-            <a:normAutofit/>
-          </a:bodyPr>
-          <a:lstStyle/>
-          <a:p>
-            <a:pPr indent="0" marL="0">
-              <a:buNone/>
-            </a:pPr>
-            <a:r>
-              <a:rPr lang="en-US" sz="1480" b="1" dirty="0">
-                <a:solidFill>
-                  <a:srgbClr val="8A1C14"/>
-                </a:solidFill>
-                <a:latin typeface="Microsoft YaHei" pitchFamily="34" charset="0"/>
-                <a:ea typeface="Microsoft YaHei" pitchFamily="34" charset="-122"/>
-                <a:cs typeface="Microsoft YaHei" pitchFamily="34" charset="-120"/>
-              </a:rPr>
-              <a:t>覆盖原则：问题要能从知识库中找到依据，答案要能回溯到文档，而不是依赖模型记忆。</a:t>
-            </a:r>
-            <a:endParaRPr lang="en-US" sz="1480" dirty="0"/>
-          </a:p>
-        </p:txBody>
-      </p:sp>
-      <p:sp>
-        <p:nvSpPr>
-          <p:cNvPr id="32" name="Shape 30"/>
-          <p:cNvSpPr/>
-          <p:nvPr/>
-        </p:nvSpPr>
-        <p:spPr>
-          <a:xfrm>
-            <a:off x="658368" y="1060704"/>
-            <a:ext cx="10927080" cy="5321808"/>
-          </a:xfrm>
-          <a:prstGeom prst="roundRect">
-            <a:avLst>
-              <a:gd name="adj" fmla="val 687"/>
-            </a:avLst>
-          </a:prstGeom>
-          <a:solidFill>
-            <a:srgbClr val="FFFFFF"/>
-          </a:solidFill>
-          <a:ln w="12700">
-            <a:solidFill>
-              <a:srgbClr val="CBD5E1"/>
-            </a:solidFill>
-            <a:prstDash val="solid"/>
-          </a:ln>
         </p:spPr>
       </p:sp>
       <p:pic>
         <p:nvPicPr>
-          <p:cNvPr id="33" name="Image 0" descr="slides/assets/knowledge_base_overview.png">    </p:cNvPr>
+          <p:cNvPr id="7" name="Image 0" descr="slides/assets/knowledge_base_overview.png">    </p:cNvPr>
           <p:cNvPicPr>
             <a:picLocks noChangeAspect="1"/>
           </p:cNvPicPr>
@@ -12129,8 +8335,8 @@
         </p:blipFill>
         <p:spPr>
           <a:xfrm>
-            <a:off x="713232" y="1115568"/>
-            <a:ext cx="10817352" cy="5212080"/>
+            <a:off x="713232" y="1133856"/>
+            <a:ext cx="10817352" cy="5175504"/>
           </a:xfrm>
           <a:prstGeom prst="rect">
             <a:avLst/>

</xml_diff>